<commit_message>
fix(presentation): update VirasatX content with accurate, verified claims and zero visual design changes
</commit_message>
<xml_diff>
--- a/sih_presentation/SIH2026_VirasatX_Idea_Submission.pptx
+++ b/sih_presentation/SIH2026_VirasatX_Idea_Submission.pptx
@@ -3161,7 +3161,7 @@
         </p:nvSpPr>
         <p:spPr>
           <a:xfrm>
-            <a:off x="1371600" y="1188720"/>
+            <a:off x="1371600" y="1115568"/>
             <a:ext cx="9448495" cy="548640"/>
           </a:xfrm>
           <a:prstGeom prst="rect">
@@ -3176,7 +3176,7 @@
           <a:lstStyle/>
           <a:p>
             <a:pPr algn="ctr">
-              <a:defRPr sz="3000" b="1">
+              <a:defRPr sz="3200" b="1">
                 <a:solidFill>
                   <a:srgbClr val="000000"/>
                 </a:solidFill>
@@ -3184,14 +3184,50 @@
               </a:defRPr>
             </a:pPr>
             <a:r>
-              <a:t>TITLE PAGE</a:t>
+              <a:t>VIRASATX</a:t>
+            </a:r>
+          </a:p>
+        </p:txBody>
+      </p:sp>
+      <p:sp>
+        <p:nvSpPr>
+          <p:cNvPr id="5" name="TextBox 4"/>
+          <p:cNvSpPr txBox="1"/>
+          <p:nvPr/>
+        </p:nvSpPr>
+        <p:spPr>
+          <a:xfrm>
+            <a:off x="1371600" y="1572768"/>
+            <a:ext cx="9448495" cy="365760"/>
+          </a:xfrm>
+          <a:prstGeom prst="rect">
+            <a:avLst/>
+          </a:prstGeom>
+          <a:noFill/>
+        </p:spPr>
+        <p:txBody>
+          <a:bodyPr wrap="none">
+            <a:spAutoFit/>
+          </a:bodyPr>
+          <a:lstStyle/>
+          <a:p>
+            <a:pPr algn="ctr">
+              <a:defRPr sz="1650" b="1">
+                <a:solidFill>
+                  <a:srgbClr val="1E293B"/>
+                </a:solidFill>
+                <a:latin typeface="Arial"/>
+              </a:defRPr>
+            </a:pPr>
+            <a:r>
+              <a:t>India’s Heritage, Understood, Preserved &amp; Experienced</a:t>
             </a:r>
           </a:p>
         </p:txBody>
       </p:sp>
       <p:pic>
         <p:nvPicPr>
-          <p:cNvPr id="5" name="Picture 4" descr="sih_bulb.png"/>
+          <p:cNvPr id="6" name="Picture 5" descr="sih_bulb.png"/>
           <p:cNvPicPr>
             <a:picLocks noChangeAspect="1"/>
           </p:cNvPicPr>
@@ -3205,7 +3241,7 @@
         </p:blipFill>
         <p:spPr>
           <a:xfrm>
-            <a:off x="4754880" y="1371600"/>
+            <a:off x="4754880" y="1417320"/>
             <a:ext cx="3474720" cy="3909060"/>
           </a:xfrm>
           <a:prstGeom prst="rect">
@@ -3215,7 +3251,7 @@
       </p:pic>
       <p:sp>
         <p:nvSpPr>
-          <p:cNvPr id="6" name="TextBox 5"/>
+          <p:cNvPr id="7" name="TextBox 6"/>
           <p:cNvSpPr txBox="1"/>
           <p:nvPr/>
         </p:nvSpPr>
@@ -3237,20 +3273,20 @@
           <a:p>
             <a:pPr>
               <a:spcAft>
-                <a:spcPts val="1300"/>
-              </a:spcAft>
-            </a:pPr>
-            <a:r>
-              <a:rPr sz="1700" b="1">
-                <a:solidFill>
-                  <a:srgbClr val="000000"/>
-                </a:solidFill>
-                <a:latin typeface="Arial"/>
-              </a:rPr>
-              <a:t>• Problem Statement ID –</a:t>
-            </a:r>
-            <a:r>
-              <a:rPr sz="1700" b="1" u="sng">
+                <a:spcPts val="800"/>
+              </a:spcAft>
+            </a:pPr>
+            <a:r>
+              <a:rPr sz="1550" b="1">
+                <a:solidFill>
+                  <a:srgbClr val="000000"/>
+                </a:solidFill>
+                <a:latin typeface="Arial"/>
+              </a:rPr>
+              <a:t>• Problem Statement ID – </a:t>
+            </a:r>
+            <a:r>
+              <a:rPr sz="1550" b="1" u="sng">
                 <a:solidFill>
                   <a:srgbClr val="000000"/>
                 </a:solidFill>
@@ -3262,62 +3298,61 @@
           <a:p>
             <a:pPr>
               <a:spcAft>
-                <a:spcPts val="1300"/>
-              </a:spcAft>
-            </a:pPr>
-            <a:r>
-              <a:rPr sz="1700" b="1">
-                <a:solidFill>
-                  <a:srgbClr val="000000"/>
-                </a:solidFill>
-                <a:latin typeface="Arial"/>
-              </a:rPr>
-              <a:t>• Problem Statement Title-</a:t>
-            </a:r>
-            <a:r>
-              <a:rPr sz="1650" b="1" u="none">
-                <a:solidFill>
-                  <a:srgbClr val="000000"/>
-                </a:solidFill>
-                <a:latin typeface="Arial"/>
-              </a:rPr>
-              <a:t>Development of AI-powered Digital Heritage Repository &amp; WebGIS-based Decision Support System (DSS) for Cultural Preservation, Provenance &amp; Living Traditions.
-(States to be concentrated: Madhya Pradesh, Tripura , Odisha, Telangana, Rajasthan)</a:t>
-            </a:r>
-          </a:p>
-          <a:p>
-            <a:pPr>
-              <a:spcAft>
-                <a:spcPts val="1300"/>
-              </a:spcAft>
-            </a:pPr>
-            <a:r>
-              <a:rPr sz="1700" b="1">
-                <a:solidFill>
-                  <a:srgbClr val="000000"/>
-                </a:solidFill>
-                <a:latin typeface="Arial"/>
-              </a:rPr>
-              <a:t>• Theme-</a:t>
-            </a:r>
-            <a:r>
-              <a:rPr sz="1700" b="1" u="sng">
-                <a:solidFill>
-                  <a:srgbClr val="000000"/>
-                </a:solidFill>
-                <a:latin typeface="Arial"/>
-              </a:rPr>
-              <a:t>Miscellaneous</a:t>
-            </a:r>
-          </a:p>
-          <a:p>
-            <a:pPr>
-              <a:spcAft>
-                <a:spcPts val="1300"/>
-              </a:spcAft>
-            </a:pPr>
-            <a:r>
-              <a:rPr sz="1700" b="1">
+                <a:spcPts val="800"/>
+              </a:spcAft>
+            </a:pPr>
+            <a:r>
+              <a:rPr sz="1550" b="1">
+                <a:solidFill>
+                  <a:srgbClr val="000000"/>
+                </a:solidFill>
+                <a:latin typeface="Arial"/>
+              </a:rPr>
+              <a:t>• Problem Statement- </a:t>
+            </a:r>
+            <a:r>
+              <a:rPr sz="1500" b="1" u="none">
+                <a:solidFill>
+                  <a:srgbClr val="000000"/>
+                </a:solidFill>
+                <a:latin typeface="Arial"/>
+              </a:rPr>
+              <a:t>Student Innovation—Ideas that showcase the rich cultural heritage and traditions of India.</a:t>
+            </a:r>
+          </a:p>
+          <a:p>
+            <a:pPr>
+              <a:spcAft>
+                <a:spcPts val="800"/>
+              </a:spcAft>
+            </a:pPr>
+            <a:r>
+              <a:rPr sz="1550" b="1">
+                <a:solidFill>
+                  <a:srgbClr val="000000"/>
+                </a:solidFill>
+                <a:latin typeface="Arial"/>
+              </a:rPr>
+              <a:t>• Theme- </a:t>
+            </a:r>
+            <a:r>
+              <a:rPr sz="1550" b="1" u="sng">
+                <a:solidFill>
+                  <a:srgbClr val="000000"/>
+                </a:solidFill>
+                <a:latin typeface="Arial"/>
+              </a:rPr>
+              <a:t>Heritage &amp; Culture</a:t>
+            </a:r>
+          </a:p>
+          <a:p>
+            <a:pPr>
+              <a:spcAft>
+                <a:spcPts val="800"/>
+              </a:spcAft>
+            </a:pPr>
+            <a:r>
+              <a:rPr sz="1550" b="1">
                 <a:solidFill>
                   <a:srgbClr val="000000"/>
                 </a:solidFill>
@@ -3326,7 +3361,7 @@
               <a:t>• PS Category- </a:t>
             </a:r>
             <a:r>
-              <a:rPr sz="1700" b="1" u="sng">
+              <a:rPr sz="1550" b="1" u="sng">
                 <a:solidFill>
                   <a:srgbClr val="000000"/>
                 </a:solidFill>
@@ -3338,11 +3373,61 @@
           <a:p>
             <a:pPr>
               <a:spcAft>
-                <a:spcPts val="1300"/>
-              </a:spcAft>
-            </a:pPr>
-            <a:r>
-              <a:rPr sz="1700" b="1">
+                <a:spcPts val="800"/>
+              </a:spcAft>
+            </a:pPr>
+            <a:r>
+              <a:rPr sz="1550" b="1">
+                <a:solidFill>
+                  <a:srgbClr val="000000"/>
+                </a:solidFill>
+                <a:latin typeface="Arial"/>
+              </a:rPr>
+              <a:t>• Organization- </a:t>
+            </a:r>
+            <a:r>
+              <a:rPr sz="1550" b="1" u="none">
+                <a:solidFill>
+                  <a:srgbClr val="000000"/>
+                </a:solidFill>
+                <a:latin typeface="Arial"/>
+              </a:rPr>
+              <a:t>AICTE</a:t>
+            </a:r>
+          </a:p>
+          <a:p>
+            <a:pPr>
+              <a:spcAft>
+                <a:spcPts val="800"/>
+              </a:spcAft>
+            </a:pPr>
+            <a:r>
+              <a:rPr sz="1550" b="1">
+                <a:solidFill>
+                  <a:srgbClr val="000000"/>
+                </a:solidFill>
+                <a:latin typeface="Arial"/>
+              </a:rPr>
+              <a:t>• Project Pitch- </a:t>
+            </a:r>
+            <a:r>
+              <a:rPr sz="1500" b="1" u="none">
+                <a:solidFill>
+                  <a:srgbClr val="000000"/>
+                </a:solidFill>
+                <a:latin typeface="Arial"/>
+              </a:rPr>
+              <a:t>“An AI-powered digital heritage ecosystem that connects monuments, artifacts, traditions, places, people and knowledge into one discoverable cultural experience.”</a:t>
+            </a:r>
+          </a:p>
+          <a:p>
+            <a:pPr>
+              <a:spcAft>
+                <a:spcPts val="800"/>
+              </a:spcAft>
+            </a:pPr>
+            <a:r>
+              <a:rPr sz="1550" b="1">
                 <a:solidFill>
                   <a:srgbClr val="000000"/>
                 </a:solidFill>
@@ -3351,7 +3436,7 @@
               <a:t>• Team ID- </a:t>
             </a:r>
             <a:r>
-              <a:rPr sz="1700" b="1" u="none">
+              <a:rPr sz="1550" b="1" u="none">
                 <a:solidFill>
                   <a:srgbClr val="000000"/>
                 </a:solidFill>
@@ -3363,11 +3448,11 @@
           <a:p>
             <a:pPr>
               <a:spcAft>
-                <a:spcPts val="1300"/>
-              </a:spcAft>
-            </a:pPr>
-            <a:r>
-              <a:rPr sz="1700" b="1">
+                <a:spcPts val="800"/>
+              </a:spcAft>
+            </a:pPr>
+            <a:r>
+              <a:rPr sz="1550" b="1">
                 <a:solidFill>
                   <a:srgbClr val="000000"/>
                 </a:solidFill>
@@ -3376,7 +3461,7 @@
               <a:t>• Team Name- </a:t>
             </a:r>
             <a:r>
-              <a:rPr sz="1700" b="1" u="none">
+              <a:rPr sz="1550" b="1" u="none">
                 <a:solidFill>
                   <a:srgbClr val="000000"/>
                 </a:solidFill>
@@ -3389,7 +3474,7 @@
       </p:sp>
       <p:sp>
         <p:nvSpPr>
-          <p:cNvPr id="7" name="TextBox 6"/>
+          <p:cNvPr id="8" name="TextBox 7"/>
           <p:cNvSpPr txBox="1"/>
           <p:nvPr/>
         </p:nvSpPr>
@@ -3690,9 +3775,9 @@
           <a:p>
             <a:pPr>
               <a:spcAft>
-                <a:spcPts val="600"/>
-              </a:spcAft>
-              <a:defRPr sz="1800" b="1">
+                <a:spcPts val="400"/>
+              </a:spcAft>
+              <a:defRPr sz="1700" b="1">
                 <a:solidFill>
                   <a:srgbClr val="0070C0"/>
                 </a:solidFill>
@@ -3706,235 +3791,276 @@
           <a:p>
             <a:pPr>
               <a:spcAft>
-                <a:spcPts val="400"/>
-              </a:spcAft>
-            </a:pPr>
-            <a:r>
-              <a:rPr sz="1100" b="1" u="sng">
+                <a:spcPts val="300"/>
+              </a:spcAft>
+            </a:pPr>
+            <a:r>
+              <a:rPr sz="950" b="1" u="sng">
                 <a:solidFill>
                   <a:srgbClr val="15803D"/>
                 </a:solidFill>
                 <a:latin typeface="Arial"/>
               </a:rPr>
-              <a:t>• Unified Digital Heritage Portal :
-</a:t>
-            </a:r>
-            <a:r>
-              <a:rPr sz="1050">
-                <a:solidFill>
-                  <a:srgbClr val="000000"/>
-                </a:solidFill>
-                <a:latin typeface="Arial"/>
-              </a:rPr>
-              <a:t>  Comprehensive repository linking monuments, artifacts, manuscripts, and living traditions.</a:t>
-            </a:r>
-          </a:p>
-          <a:p>
-            <a:pPr>
-              <a:spcAft>
-                <a:spcPts val="400"/>
-              </a:spcAft>
-            </a:pPr>
-            <a:r>
-              <a:rPr sz="1100" b="1" u="sng">
+              <a:t>• Fragmented Knowledge &amp; Passive Discovery : </a:t>
+            </a:r>
+            <a:r>
+              <a:rPr sz="950">
+                <a:solidFill>
+                  <a:srgbClr val="000000"/>
+                </a:solidFill>
+                <a:latin typeface="Arial"/>
+              </a:rPr>
+              <a:t>Heritage information is distributed across monuments, archives, museums and disconnected sources; digital heritage is often presented as isolated information.</a:t>
+            </a:r>
+          </a:p>
+          <a:p>
+            <a:pPr>
+              <a:spcAft>
+                <a:spcPts val="300"/>
+              </a:spcAft>
+            </a:pPr>
+            <a:r>
+              <a:rPr sz="950" b="1" u="sng">
                 <a:solidFill>
                   <a:srgbClr val="15803D"/>
                 </a:solidFill>
                 <a:latin typeface="Arial"/>
               </a:rPr>
-              <a:t>• Digital Witness &amp; Testimony:
-</a:t>
-            </a:r>
-            <a:r>
-              <a:rPr sz="1050">
-                <a:solidFill>
-                  <a:srgbClr val="000000"/>
-                </a:solidFill>
-                <a:latin typeface="Arial"/>
-              </a:rPr>
-              <a:t>  Oral histories, artisan testimonies, and video records stored securely as valid proof.</a:t>
-            </a:r>
-          </a:p>
-          <a:p>
-            <a:pPr>
-              <a:spcAft>
-                <a:spcPts val="400"/>
-              </a:spcAft>
-            </a:pPr>
-            <a:r>
-              <a:rPr sz="1100" b="1" u="sng">
+              <a:t>• Low Discoverability &amp; Context Gap : </a:t>
+            </a:r>
+            <a:r>
+              <a:rPr sz="950">
+                <a:solidFill>
+                  <a:srgbClr val="000000"/>
+                </a:solidFill>
+                <a:latin typeface="Arial"/>
+              </a:rPr>
+              <a:t>Traditional crafts, artisans and living heritage are hard to discover; understanding wider connections to history, place and community is fragmented.</a:t>
+            </a:r>
+          </a:p>
+          <a:p>
+            <a:pPr>
+              <a:spcAft>
+                <a:spcPts val="300"/>
+              </a:spcAft>
+            </a:pPr>
+            <a:r>
+              <a:rPr sz="950" b="1" u="sng">
                 <a:solidFill>
                   <a:srgbClr val="15803D"/>
                 </a:solidFill>
                 <a:latin typeface="Arial"/>
               </a:rPr>
-              <a:t>• Title Insurance / Digital Patta :
-</a:t>
-            </a:r>
-            <a:r>
-              <a:rPr sz="1050">
-                <a:solidFill>
-                  <a:srgbClr val="000000"/>
-                </a:solidFill>
-                <a:latin typeface="Arial"/>
-              </a:rPr>
-              <a:t>  Ensures authenticity with secure blockchain-backed provenance and artifact registration.</a:t>
-            </a:r>
-          </a:p>
-          <a:p>
-            <a:pPr>
-              <a:spcAft>
-                <a:spcPts val="400"/>
-              </a:spcAft>
-            </a:pPr>
-            <a:r>
-              <a:rPr sz="1100" b="1" u="sng">
+              <a:t>• Proposed Solution — Unified Discovery Platform : </a:t>
+            </a:r>
+            <a:r>
+              <a:rPr sz="950">
+                <a:solidFill>
+                  <a:srgbClr val="000000"/>
+                </a:solidFill>
+                <a:latin typeface="Arial"/>
+              </a:rPr>
+              <a:t>VirasatX brings these discovery pathways together through one interconnected digital heritage experience.</a:t>
+            </a:r>
+          </a:p>
+          <a:p>
+            <a:pPr>
+              <a:spcAft>
+                <a:spcPts val="300"/>
+              </a:spcAft>
+            </a:pPr>
+            <a:r>
+              <a:rPr sz="950" b="1" u="sng">
                 <a:solidFill>
                   <a:srgbClr val="15803D"/>
                 </a:solidFill>
                 <a:latin typeface="Arial"/>
               </a:rPr>
-              <a:t>• Grievance Resolution &amp; Illegal Alerts:
-</a:t>
-            </a:r>
-            <a:r>
-              <a:rPr sz="1050">
-                <a:solidFill>
-                  <a:srgbClr val="000000"/>
-                </a:solidFill>
-                <a:latin typeface="Arial"/>
-              </a:rPr>
-              <a:t>  Efficient heritage grievance handling and unauthorized land encroachment warnings.</a:t>
-            </a:r>
-          </a:p>
-          <a:p>
-            <a:pPr>
-              <a:spcAft>
-                <a:spcPts val="400"/>
-              </a:spcAft>
-            </a:pPr>
-            <a:r>
-              <a:rPr sz="1100" b="1" u="sng">
+              <a:t>• Heritage Collections &amp; Artifact Exploration : </a:t>
+            </a:r>
+            <a:r>
+              <a:rPr sz="950">
+                <a:solidFill>
+                  <a:srgbClr val="000000"/>
+                </a:solidFill>
+                <a:latin typeface="Arial"/>
+              </a:rPr>
+              <a:t>Detailed digital exploration of cultural artifacts, contextual narratives, and historical background.</a:t>
+            </a:r>
+          </a:p>
+          <a:p>
+            <a:pPr>
+              <a:spcAft>
+                <a:spcPts val="300"/>
+              </a:spcAft>
+            </a:pPr>
+            <a:r>
+              <a:rPr sz="950" b="1" u="sng">
                 <a:solidFill>
                   <a:srgbClr val="15803D"/>
                 </a:solidFill>
                 <a:latin typeface="Arial"/>
               </a:rPr>
-              <a:t>• AI Disciplinary Dashboard :
-</a:t>
-            </a:r>
-            <a:r>
-              <a:rPr sz="1050">
-                <a:solidFill>
-                  <a:srgbClr val="000000"/>
-                </a:solidFill>
-                <a:latin typeface="Arial"/>
-              </a:rPr>
-              <a:t>  Suggests actions and tracks officer and institutional cataloging accountability.</a:t>
-            </a:r>
-          </a:p>
-          <a:p>
-            <a:pPr>
-              <a:spcAft>
-                <a:spcPts val="400"/>
-              </a:spcAft>
-            </a:pPr>
-            <a:r>
-              <a:rPr sz="1100" b="1" u="sng">
+              <a:t>• Chronological Cultural Timeline : </a:t>
+            </a:r>
+            <a:r>
+              <a:rPr sz="950">
+                <a:solidFill>
+                  <a:srgbClr val="000000"/>
+                </a:solidFill>
+                <a:latin typeface="Arial"/>
+              </a:rPr>
+              <a:t>Chronological exploration of Indian heritage across major historical periods and epochs.</a:t>
+            </a:r>
+          </a:p>
+          <a:p>
+            <a:pPr>
+              <a:spcAft>
+                <a:spcPts val="300"/>
+              </a:spcAft>
+            </a:pPr>
+            <a:r>
+              <a:rPr sz="950" b="1" u="sng">
                 <a:solidFill>
                   <a:srgbClr val="15803D"/>
                 </a:solidFill>
                 <a:latin typeface="Arial"/>
               </a:rPr>
-              <a:t>• Analytics-Driven Officer Monitoring:
-</a:t>
-            </a:r>
-            <a:r>
-              <a:rPr sz="1050">
-                <a:solidFill>
-                  <a:srgbClr val="000000"/>
-                </a:solidFill>
-                <a:latin typeface="Arial"/>
-              </a:rPr>
-              <a:t>  Tracks verification time, claim outcomes, and conservation grievances reported.</a:t>
-            </a:r>
-          </a:p>
-          <a:p>
-            <a:pPr>
-              <a:spcAft>
-                <a:spcPts val="400"/>
-              </a:spcAft>
-            </a:pPr>
-            <a:r>
-              <a:rPr sz="1100" b="1" u="sng">
+              <a:t>• Interactive Heritage Map : </a:t>
+            </a:r>
+            <a:r>
+              <a:rPr sz="950">
+                <a:solidFill>
+                  <a:srgbClr val="000000"/>
+                </a:solidFill>
+                <a:latin typeface="Arial"/>
+              </a:rPr>
+              <a:t>Geographical exploration linking monuments, regional heritage sites, and cultural traditions.</a:t>
+            </a:r>
+          </a:p>
+          <a:p>
+            <a:pPr>
+              <a:spcAft>
+                <a:spcPts val="300"/>
+              </a:spcAft>
+            </a:pPr>
+            <a:r>
+              <a:rPr sz="950" b="1" u="sng">
                 <a:solidFill>
                   <a:srgbClr val="15803D"/>
                 </a:solidFill>
                 <a:latin typeface="Arial"/>
               </a:rPr>
-              <a:t>• Interactive Virasat Web-GIS Atlas:
-</a:t>
-            </a:r>
-            <a:r>
-              <a:rPr sz="1050">
-                <a:solidFill>
-                  <a:srgbClr val="000000"/>
-                </a:solidFill>
-                <a:latin typeface="Arial"/>
-              </a:rPr>
-              <a:t>  Dynamic platform for exploring heritage assets, ancient corridors, and excavation sites.</a:t>
-            </a:r>
-          </a:p>
-          <a:p>
-            <a:pPr>
-              <a:spcAft>
-                <a:spcPts val="400"/>
-              </a:spcAft>
-            </a:pPr>
-            <a:r>
-              <a:rPr sz="1100" b="1" u="sng">
+              <a:t>• Living Traditions &amp; Artisan Discovery : </a:t>
+            </a:r>
+            <a:r>
+              <a:rPr sz="950">
+                <a:solidFill>
+                  <a:srgbClr val="000000"/>
+                </a:solidFill>
+                <a:latin typeface="Arial"/>
+              </a:rPr>
+              <a:t>Dedicated discovery pathway for traditional crafts, artisans, communities, and cultural practices.</a:t>
+            </a:r>
+          </a:p>
+          <a:p>
+            <a:pPr>
+              <a:spcAft>
+                <a:spcPts val="300"/>
+              </a:spcAft>
+            </a:pPr>
+            <a:r>
+              <a:rPr sz="950" b="1" u="sng">
                 <a:solidFill>
                   <a:srgbClr val="15803D"/>
                 </a:solidFill>
                 <a:latin typeface="Arial"/>
               </a:rPr>
-              <a:t>• AI Disputes Mediator:
-</a:t>
-            </a:r>
-            <a:r>
-              <a:rPr sz="1050">
-                <a:solidFill>
-                  <a:srgbClr val="000000"/>
-                </a:solidFill>
-                <a:latin typeface="Arial"/>
-              </a:rPr>
-              <a:t>  Resolving conflicts and contested claims within existing legal frameworks.</a:t>
-            </a:r>
-          </a:p>
-          <a:p>
-            <a:pPr>
-              <a:spcAft>
-                <a:spcPts val="400"/>
-              </a:spcAft>
-            </a:pPr>
-            <a:r>
-              <a:rPr sz="1100" b="1" u="sng">
+              <a:t>• AI Heritage Guide &amp; Visual Iconography AI : </a:t>
+            </a:r>
+            <a:r>
+              <a:rPr sz="950">
+                <a:solidFill>
+                  <a:srgbClr val="000000"/>
+                </a:solidFill>
+                <a:latin typeface="Arial"/>
+              </a:rPr>
+              <a:t>AI-assisted heritage guidance for contextual exploration and AI-assisted visual iconography discovery.</a:t>
+            </a:r>
+          </a:p>
+          <a:p>
+            <a:pPr>
+              <a:spcAft>
+                <a:spcPts val="300"/>
+              </a:spcAft>
+            </a:pPr>
+            <a:r>
+              <a:rPr sz="950" b="1" u="sng">
                 <a:solidFill>
                   <a:srgbClr val="15803D"/>
                 </a:solidFill>
                 <a:latin typeface="Arial"/>
               </a:rPr>
-              <a:t>• GI Tagging and E-Signature :
-</a:t>
-            </a:r>
-            <a:r>
-              <a:rPr sz="1050">
-                <a:solidFill>
-                  <a:srgbClr val="000000"/>
-                </a:solidFill>
-                <a:latin typeface="Arial"/>
-              </a:rPr>
-              <a:t>  To preserve cultural heritage safeguard traditional products and paperless approval .</a:t>
+              <a:t>• Manuscripts &amp; Structured Learning : </a:t>
+            </a:r>
+            <a:r>
+              <a:rPr sz="950">
+                <a:solidFill>
+                  <a:srgbClr val="000000"/>
+                </a:solidFill>
+                <a:latin typeface="Arial"/>
+              </a:rPr>
+              <a:t>Dedicated exploration of textual and inscriptional heritage with structured learning and responsible discovery.</a:t>
+            </a:r>
+          </a:p>
+          <a:p>
+            <a:pPr>
+              <a:spcAft>
+                <a:spcPts val="300"/>
+              </a:spcAft>
+            </a:pPr>
+            <a:r>
+              <a:rPr sz="950" b="1" u="sng">
+                <a:solidFill>
+                  <a:srgbClr val="15803D"/>
+                </a:solidFill>
+                <a:latin typeface="Arial"/>
+              </a:rPr>
+              <a:t>• Unique Value Proposition (UVP) : </a:t>
+            </a:r>
+            <a:r>
+              <a:rPr sz="950">
+                <a:solidFill>
+                  <a:srgbClr val="000000"/>
+                </a:solidFill>
+                <a:latin typeface="Arial"/>
+              </a:rPr>
+              <a:t>Artifact → Story → Period → Place → Tradition → Community → Learning → Responsible Experience.</a:t>
+            </a:r>
+          </a:p>
+          <a:p>
+            <a:pPr>
+              <a:spcAft>
+                <a:spcPts val="300"/>
+              </a:spcAft>
+            </a:pPr>
+            <a:r>
+              <a:rPr sz="950" b="1" u="sng">
+                <a:solidFill>
+                  <a:srgbClr val="15803D"/>
+                </a:solidFill>
+                <a:latin typeface="Arial"/>
+              </a:rPr>
+              <a:t>• Cultural Context Focus : </a:t>
+            </a:r>
+            <a:r>
+              <a:rPr sz="950">
+                <a:solidFill>
+                  <a:srgbClr val="000000"/>
+                </a:solidFill>
+                <a:latin typeface="Arial"/>
+              </a:rPr>
+              <a:t>“VirasatX connects the cultural context around heritage — not just the heritage object itself.”</a:t>
             </a:r>
           </a:p>
         </p:txBody>
@@ -4288,7 +4414,7 @@
                 </a:solidFill>
                 <a:latin typeface="Arial"/>
               </a:rPr>
-              <a:t>• Data Extraction: </a:t>
+              <a:t>• Frontend Framework: </a:t>
             </a:r>
             <a:r>
               <a:rPr sz="950">
@@ -4297,7 +4423,7 @@
                 </a:solidFill>
                 <a:latin typeface="Arial"/>
               </a:rPr>
-              <a:t>Optical Character Recogntion(OCR), NLP.</a:t>
+              <a:t>React 19, TypeScript, Vite &amp; Tailwind CSS with Motion.</a:t>
             </a:r>
           </a:p>
           <a:p>
@@ -4313,7 +4439,7 @@
                 </a:solidFill>
                 <a:latin typeface="Arial"/>
               </a:rPr>
-              <a:t>• WebGIS platform: </a:t>
+              <a:t>• AI Heritage Guide: </a:t>
             </a:r>
             <a:r>
               <a:rPr sz="950">
@@ -4322,7 +4448,7 @@
                 </a:solidFill>
                 <a:latin typeface="Arial"/>
               </a:rPr>
-              <a:t>Leaflet.js(for interactive maps).</a:t>
+              <a:t>Google Gemini Multimodal AI for contextual cultural exploration.</a:t>
             </a:r>
           </a:p>
           <a:p>
@@ -4338,7 +4464,7 @@
                 </a:solidFill>
                 <a:latin typeface="Arial"/>
               </a:rPr>
-              <a:t>• Asset Mapping: </a:t>
+              <a:t>• Visual Iconography AI: </a:t>
             </a:r>
             <a:r>
               <a:rPr sz="950">
@@ -4347,7 +4473,7 @@
                 </a:solidFill>
                 <a:latin typeface="Arial"/>
               </a:rPr>
-              <a:t>Random Forest &amp; CNN.</a:t>
+              <a:t>AI-assisted visual guidance for iconography and motif discovery.</a:t>
             </a:r>
           </a:p>
           <a:p>
@@ -4363,7 +4489,7 @@
                 </a:solidFill>
                 <a:latin typeface="Arial"/>
               </a:rPr>
-              <a:t>• Data Storage: </a:t>
+              <a:t>• Interactive Mapping: </a:t>
             </a:r>
             <a:r>
               <a:rPr sz="950">
@@ -4372,7 +4498,7 @@
                 </a:solidFill>
                 <a:latin typeface="Arial"/>
               </a:rPr>
-              <a:t>PostgreSQl &amp; PostGIS(for geospatial data).</a:t>
+              <a:t>Leaflet / OpenStreetMap for geographical heritage discovery.</a:t>
             </a:r>
           </a:p>
           <a:p>
@@ -4388,7 +4514,7 @@
                 </a:solidFill>
                 <a:latin typeface="Arial"/>
               </a:rPr>
-              <a:t>• Data Management: </a:t>
+              <a:t>• 3D Exploration Studio: </a:t>
             </a:r>
             <a:r>
               <a:rPr sz="950">
@@ -4397,7 +4523,7 @@
                 </a:solidFill>
                 <a:latin typeface="Arial"/>
               </a:rPr>
-              <a:t>Cloud Object Storage &amp; MySQL(Structured).</a:t>
+              <a:t>Three.js &amp; WebGL for interactive 3D artifact exploration.</a:t>
             </a:r>
           </a:p>
           <a:p>
@@ -4413,7 +4539,7 @@
                 </a:solidFill>
                 <a:latin typeface="Arial"/>
               </a:rPr>
-              <a:t>• GeoServer: </a:t>
+              <a:t>• Voice Interaction: </a:t>
             </a:r>
             <a:r>
               <a:rPr sz="950">
@@ -4422,7 +4548,7 @@
                 </a:solidFill>
                 <a:latin typeface="Arial"/>
               </a:rPr>
-              <a:t>Use standard protocols WMS and WFS to serve maps.</a:t>
+              <a:t>Web Speech API for voice-assisted queries and audio guidance.</a:t>
             </a:r>
           </a:p>
           <a:p>
@@ -4438,7 +4564,7 @@
                 </a:solidFill>
                 <a:latin typeface="Arial"/>
               </a:rPr>
-              <a:t>• Decision Support System: </a:t>
+              <a:t>• Backend &amp; Database: </a:t>
             </a:r>
             <a:r>
               <a:rPr sz="950">
@@ -4447,7 +4573,7 @@
                 </a:solidFill>
                 <a:latin typeface="Arial"/>
               </a:rPr>
-              <a:t>for scheme recommendations.</a:t>
+              <a:t>Supabase with PostgreSQL database and Row Level Security (RLS).</a:t>
             </a:r>
           </a:p>
           <a:p>
@@ -4463,7 +4589,7 @@
                 </a:solidFill>
                 <a:latin typeface="Arial"/>
               </a:rPr>
-              <a:t>• Blockchain based Security: </a:t>
+              <a:t>• Secure Authentication: </a:t>
             </a:r>
             <a:r>
               <a:rPr sz="950">
@@ -4472,7 +4598,7 @@
                 </a:solidFill>
                 <a:latin typeface="Arial"/>
               </a:rPr>
-              <a:t>Hyperledger Fabric.</a:t>
+              <a:t>Supabase Auth with role-based access control policies.</a:t>
             </a:r>
           </a:p>
           <a:p>
@@ -4488,7 +4614,7 @@
                 </a:solidFill>
                 <a:latin typeface="Arial"/>
               </a:rPr>
-              <a:t>• Key Lock Framework: </a:t>
+              <a:t>• Cloud Deployment: </a:t>
             </a:r>
             <a:r>
               <a:rPr sz="950">
@@ -4497,7 +4623,7 @@
                 </a:solidFill>
                 <a:latin typeface="Arial"/>
               </a:rPr>
-              <a:t>Open-source Identity &amp; Access Management</a:t>
+              <a:t>Vercel serverless edge deployment for global responsiveness.</a:t>
             </a:r>
           </a:p>
           <a:p>
@@ -4513,7 +4639,7 @@
                 </a:solidFill>
                 <a:latin typeface="Arial"/>
               </a:rPr>
-              <a:t>• Rasa: </a:t>
+              <a:t>• Scalable Architecture: </a:t>
             </a:r>
             <a:r>
               <a:rPr sz="950">
@@ -4522,7 +4648,7 @@
                 </a:solidFill>
                 <a:latin typeface="Arial"/>
               </a:rPr>
-              <a:t>Preferred for its offline, multilingual, and secure chatbot.</a:t>
+              <a:t>Modular component hierarchy with structured content schemas.</a:t>
             </a:r>
           </a:p>
         </p:txBody>
@@ -4829,7 +4955,7 @@
           <a:lstStyle/>
           <a:p>
             <a:pPr algn="ctr">
-              <a:defRPr sz="2400" b="1">
+              <a:defRPr sz="2200" b="1">
                 <a:solidFill>
                   <a:srgbClr val="000000"/>
                 </a:solidFill>
@@ -4837,7 +4963,7 @@
               </a:defRPr>
             </a:pPr>
             <a:r>
-              <a:t>FEASIBILITY AND VIABILITY</a:t>
+              <a:t>WHAT MAKES VIRASATX DIFFERENT?</a:t>
             </a:r>
           </a:p>
         </p:txBody>
@@ -4971,9 +5097,9 @@
           <a:p>
             <a:pPr>
               <a:spcAft>
-                <a:spcPts val="400"/>
-              </a:spcAft>
-              <a:defRPr sz="1800" b="1">
+                <a:spcPts val="800"/>
+              </a:spcAft>
+              <a:defRPr sz="1700" b="1">
                 <a:solidFill>
                   <a:srgbClr val="0070C0"/>
                 </a:solidFill>
@@ -4981,13 +5107,13 @@
               </a:defRPr>
             </a:pPr>
             <a:r>
-              <a:t>❖ Feasibility:</a:t>
-            </a:r>
-          </a:p>
-          <a:p>
-            <a:pPr>
-              <a:spcAft>
-                <a:spcPts val="200"/>
+              <a:t>❖ Core Capabilities:</a:t>
+            </a:r>
+          </a:p>
+          <a:p>
+            <a:pPr>
+              <a:spcAft>
+                <a:spcPts val="1000"/>
               </a:spcAft>
             </a:pPr>
             <a:r>
@@ -4997,109 +5123,23 @@
                 </a:solidFill>
                 <a:latin typeface="Arial"/>
               </a:rPr>
-              <a:t>1. Technical Feasibility:</a:t>
-            </a:r>
-          </a:p>
-          <a:p>
-            <a:pPr>
-              <a:spcAft>
-                <a:spcPts val="100"/>
-              </a:spcAft>
-            </a:pPr>
-            <a:r>
-              <a:rPr sz="1050" b="1">
-                <a:solidFill>
-                  <a:srgbClr val="000000"/>
-                </a:solidFill>
-                <a:latin typeface="Arial"/>
-              </a:rPr>
-              <a:t>1.Digitization, AI Mapping and Web-GIS Dashboards:</a:t>
-            </a:r>
-          </a:p>
-          <a:p>
-            <a:pPr>
-              <a:spcAft>
-                <a:spcPts val="100"/>
-              </a:spcAft>
-            </a:pPr>
-            <a:r>
-              <a:rPr sz="1000">
-                <a:solidFill>
-                  <a:srgbClr val="000000"/>
-                </a:solidFill>
-                <a:latin typeface="Arial"/>
-              </a:rPr>
-              <a:t>  • OCR and AI extract data from documents.</a:t>
-            </a:r>
-          </a:p>
-          <a:p>
-            <a:pPr>
-              <a:spcAft>
-                <a:spcPts val="100"/>
-              </a:spcAft>
-            </a:pPr>
-            <a:r>
-              <a:rPr sz="1000">
-                <a:solidFill>
-                  <a:srgbClr val="000000"/>
-                </a:solidFill>
-                <a:latin typeface="Arial"/>
-              </a:rPr>
-              <a:t>  • Web-GIS dashboards show real-time interactive maps.</a:t>
-            </a:r>
-          </a:p>
-          <a:p>
-            <a:pPr>
-              <a:spcAft>
-                <a:spcPts val="100"/>
-              </a:spcAft>
-            </a:pPr>
-            <a:r>
-              <a:rPr sz="1050" b="1">
-                <a:solidFill>
-                  <a:srgbClr val="000000"/>
-                </a:solidFill>
-                <a:latin typeface="Arial"/>
-              </a:rPr>
-              <a:t>2. DSS Integration with Blockchain Security:</a:t>
-            </a:r>
-          </a:p>
-          <a:p>
-            <a:pPr>
-              <a:spcAft>
-                <a:spcPts val="100"/>
-              </a:spcAft>
-            </a:pPr>
-            <a:r>
-              <a:rPr sz="1000">
-                <a:solidFill>
-                  <a:srgbClr val="000000"/>
-                </a:solidFill>
-                <a:latin typeface="Arial"/>
-              </a:rPr>
-              <a:t>  • AI engines match schemes to community needs.</a:t>
-            </a:r>
-          </a:p>
-          <a:p>
-            <a:pPr>
-              <a:spcAft>
-                <a:spcPts val="100"/>
-              </a:spcAft>
-            </a:pPr>
-            <a:r>
-              <a:rPr sz="1000">
-                <a:solidFill>
-                  <a:srgbClr val="000000"/>
-                </a:solidFill>
-                <a:latin typeface="Arial"/>
-              </a:rPr>
-              <a:t>  • Blockchain ensures secure, tamper-proof digital records.</a:t>
-            </a:r>
-          </a:p>
-          <a:p>
-            <a:pPr>
-              <a:spcAft>
-                <a:spcPts val="200"/>
+              <a:t>• Virasat AI :
+</a:t>
+            </a:r>
+            <a:r>
+              <a:rPr sz="1050">
+                <a:solidFill>
+                  <a:srgbClr val="000000"/>
+                </a:solidFill>
+                <a:latin typeface="Arial"/>
+              </a:rPr>
+              <a:t>  AI-assisted heritage guidance for contextual exploration and research-oriented discovery.</a:t>
+            </a:r>
+          </a:p>
+          <a:p>
+            <a:pPr>
+              <a:spcAft>
+                <a:spcPts val="1000"/>
               </a:spcAft>
             </a:pPr>
             <a:r>
@@ -5109,109 +5149,23 @@
                 </a:solidFill>
                 <a:latin typeface="Arial"/>
               </a:rPr>
-              <a:t>2. Operational Feasibility:</a:t>
-            </a:r>
-          </a:p>
-          <a:p>
-            <a:pPr>
-              <a:spcAft>
-                <a:spcPts val="100"/>
-              </a:spcAft>
-            </a:pPr>
-            <a:r>
-              <a:rPr sz="1050" b="1">
-                <a:solidFill>
-                  <a:srgbClr val="000000"/>
-                </a:solidFill>
-                <a:latin typeface="Arial"/>
-              </a:rPr>
-              <a:t>1.Existing Setup and Simple Staff Training:</a:t>
-            </a:r>
-          </a:p>
-          <a:p>
-            <a:pPr>
-              <a:spcAft>
-                <a:spcPts val="100"/>
-              </a:spcAft>
-            </a:pPr>
-            <a:r>
-              <a:rPr sz="1000">
-                <a:solidFill>
-                  <a:srgbClr val="000000"/>
-                </a:solidFill>
-                <a:latin typeface="Arial"/>
-              </a:rPr>
-              <a:t>  • Government data exists, needs proper connection.</a:t>
-            </a:r>
-          </a:p>
-          <a:p>
-            <a:pPr>
-              <a:spcAft>
-                <a:spcPts val="100"/>
-              </a:spcAft>
-            </a:pPr>
-            <a:r>
-              <a:rPr sz="1000">
-                <a:solidFill>
-                  <a:srgbClr val="000000"/>
-                </a:solidFill>
-                <a:latin typeface="Arial"/>
-              </a:rPr>
-              <a:t>  • Staff need basic training through short workshops.</a:t>
-            </a:r>
-          </a:p>
-          <a:p>
-            <a:pPr>
-              <a:spcAft>
-                <a:spcPts val="100"/>
-              </a:spcAft>
-            </a:pPr>
-            <a:r>
-              <a:rPr sz="1050" b="1">
-                <a:solidFill>
-                  <a:srgbClr val="000000"/>
-                </a:solidFill>
-                <a:latin typeface="Arial"/>
-              </a:rPr>
-              <a:t>2. Stakeholder Support and Effective Heritage Implementation:</a:t>
-            </a:r>
-          </a:p>
-          <a:p>
-            <a:pPr>
-              <a:spcAft>
-                <a:spcPts val="100"/>
-              </a:spcAft>
-            </a:pPr>
-            <a:r>
-              <a:rPr sz="1000">
-                <a:solidFill>
-                  <a:srgbClr val="000000"/>
-                </a:solidFill>
-                <a:latin typeface="Arial"/>
-              </a:rPr>
-              <a:t>  • Ministries and NGOs already support cultural preservation schemes.</a:t>
-            </a:r>
-          </a:p>
-          <a:p>
-            <a:pPr>
-              <a:spcAft>
-                <a:spcPts val="100"/>
-              </a:spcAft>
-            </a:pPr>
-            <a:r>
-              <a:rPr sz="1000">
-                <a:solidFill>
-                  <a:srgbClr val="000000"/>
-                </a:solidFill>
-                <a:latin typeface="Arial"/>
-              </a:rPr>
-              <a:t>  • System strengthens efforts, not replacing existing work.</a:t>
-            </a:r>
-          </a:p>
-          <a:p>
-            <a:pPr>
-              <a:spcAft>
-                <a:spcPts val="200"/>
+              <a:t>• Visual Iconography AI :
+</a:t>
+            </a:r>
+            <a:r>
+              <a:rPr sz="1050">
+                <a:solidFill>
+                  <a:srgbClr val="000000"/>
+                </a:solidFill>
+                <a:latin typeface="Arial"/>
+              </a:rPr>
+              <a:t>  AI-assisted exploration of visual cultural and iconographic information.</a:t>
+            </a:r>
+          </a:p>
+          <a:p>
+            <a:pPr>
+              <a:spcAft>
+                <a:spcPts val="1000"/>
               </a:spcAft>
             </a:pPr>
             <a:r>
@@ -5221,103 +5175,69 @@
                 </a:solidFill>
                 <a:latin typeface="Arial"/>
               </a:rPr>
-              <a:t>3. Legal &amp; Ethical Feasibility:</a:t>
-            </a:r>
-          </a:p>
-          <a:p>
-            <a:pPr>
-              <a:spcAft>
-                <a:spcPts val="100"/>
-              </a:spcAft>
-            </a:pPr>
-            <a:r>
-              <a:rPr sz="1050" b="1">
-                <a:solidFill>
-                  <a:srgbClr val="000000"/>
-                </a:solidFill>
-                <a:latin typeface="Arial"/>
-              </a:rPr>
-              <a:t>1.Data Privacy:</a:t>
-            </a:r>
-          </a:p>
-          <a:p>
-            <a:pPr>
-              <a:spcAft>
-                <a:spcPts val="100"/>
-              </a:spcAft>
-            </a:pPr>
-            <a:r>
-              <a:rPr sz="1000">
-                <a:solidFill>
-                  <a:srgbClr val="000000"/>
-                </a:solidFill>
-                <a:latin typeface="Arial"/>
-              </a:rPr>
-              <a:t>  • Must follow India’s DPDP Act, ensuring legal compliance.</a:t>
-            </a:r>
-          </a:p>
-          <a:p>
-            <a:pPr>
-              <a:spcAft>
-                <a:spcPts val="100"/>
-              </a:spcAft>
-            </a:pPr>
-            <a:r>
-              <a:rPr sz="1000">
-                <a:solidFill>
-                  <a:srgbClr val="000000"/>
-                </a:solidFill>
-                <a:latin typeface="Arial"/>
-              </a:rPr>
-              <a:t>  • Blockchain and encryption safeguard sensitive user data.</a:t>
-            </a:r>
-          </a:p>
-          <a:p>
-            <a:pPr>
-              <a:spcAft>
-                <a:spcPts val="100"/>
-              </a:spcAft>
-            </a:pPr>
-            <a:r>
-              <a:rPr sz="1050" b="1">
-                <a:solidFill>
-                  <a:srgbClr val="000000"/>
-                </a:solidFill>
-                <a:latin typeface="Arial"/>
-              </a:rPr>
-              <a:t>2. Consent Mechanism:</a:t>
-            </a:r>
-          </a:p>
-          <a:p>
-            <a:pPr>
-              <a:spcAft>
-                <a:spcPts val="100"/>
-              </a:spcAft>
-            </a:pPr>
-            <a:r>
-              <a:rPr sz="1000">
-                <a:solidFill>
-                  <a:srgbClr val="000000"/>
-                </a:solidFill>
-                <a:latin typeface="Arial"/>
-              </a:rPr>
-              <a:t>  • Artisan and community informed consent required in all processes.</a:t>
-            </a:r>
-          </a:p>
-          <a:p>
-            <a:pPr>
-              <a:spcAft>
-                <a:spcPts val="100"/>
-              </a:spcAft>
-            </a:pPr>
-            <a:r>
-              <a:rPr sz="1000">
-                <a:solidFill>
-                  <a:srgbClr val="000000"/>
-                </a:solidFill>
-                <a:latin typeface="Arial"/>
-              </a:rPr>
-              <a:t>  • Real-time feedback enables secure two-way communication.</a:t>
+              <a:t>• Heritage Atlas :
+</a:t>
+            </a:r>
+            <a:r>
+              <a:rPr sz="1050">
+                <a:solidFill>
+                  <a:srgbClr val="000000"/>
+                </a:solidFill>
+                <a:latin typeface="Arial"/>
+              </a:rPr>
+              <a:t>  Interactive geographical discovery of heritage places and regions.</a:t>
+            </a:r>
+          </a:p>
+          <a:p>
+            <a:pPr>
+              <a:spcAft>
+                <a:spcPts val="1000"/>
+              </a:spcAft>
+            </a:pPr>
+            <a:r>
+              <a:rPr sz="1100" b="1" u="sng">
+                <a:solidFill>
+                  <a:srgbClr val="15803D"/>
+                </a:solidFill>
+                <a:latin typeface="Arial"/>
+              </a:rPr>
+              <a:t>• Cultural Timeline :
+</a:t>
+            </a:r>
+            <a:r>
+              <a:rPr sz="1050">
+                <a:solidFill>
+                  <a:srgbClr val="000000"/>
+                </a:solidFill>
+                <a:latin typeface="Arial"/>
+              </a:rPr>
+              <a:t>  Chronological exploration of Indian heritage across historical periods.</a:t>
+            </a:r>
+          </a:p>
+          <a:p>
+            <a:pPr>
+              <a:spcAft>
+                <a:spcPts val="1000"/>
+              </a:spcAft>
+            </a:pPr>
+            <a:r>
+              <a:rPr sz="1100" b="1" u="sng">
+                <a:solidFill>
+                  <a:srgbClr val="15803D"/>
+                </a:solidFill>
+                <a:latin typeface="Arial"/>
+              </a:rPr>
+              <a:t>• Living Heritage :
+</a:t>
+            </a:r>
+            <a:r>
+              <a:rPr sz="1050">
+                <a:solidFill>
+                  <a:srgbClr val="000000"/>
+                </a:solidFill>
+                <a:latin typeface="Arial"/>
+              </a:rPr>
+              <a:t>  Discovery pathway for traditional crafts, artisans, communities and cultural practices.</a:t>
             </a:r>
           </a:p>
         </p:txBody>
@@ -5391,23 +5311,137 @@
           <a:p>
             <a:pPr>
               <a:spcAft>
+                <a:spcPts val="800"/>
+              </a:spcAft>
+              <a:defRPr sz="1700" b="1">
+                <a:solidFill>
+                  <a:srgbClr val="0070C0"/>
+                </a:solidFill>
+                <a:latin typeface="Arial"/>
+              </a:defRPr>
+            </a:pPr>
+            <a:r>
+              <a:t>❖ Discovery Pathways &amp; UVP:</a:t>
+            </a:r>
+          </a:p>
+          <a:p>
+            <a:pPr>
+              <a:spcAft>
+                <a:spcPts val="800"/>
+              </a:spcAft>
+            </a:pPr>
+            <a:r>
+              <a:rPr sz="1100" b="1" u="sng">
+                <a:solidFill>
+                  <a:srgbClr val="15803D"/>
+                </a:solidFill>
+                <a:latin typeface="Arial"/>
+              </a:rPr>
+              <a:t>• Manuscripts &amp; Epigraphy :
+</a:t>
+            </a:r>
+            <a:r>
+              <a:rPr sz="1050">
+                <a:solidFill>
+                  <a:srgbClr val="000000"/>
+                </a:solidFill>
+                <a:latin typeface="Arial"/>
+              </a:rPr>
+              <a:t>  Dedicated exploration of textual and inscriptional heritage.</a:t>
+            </a:r>
+          </a:p>
+          <a:p>
+            <a:pPr>
+              <a:spcAft>
+                <a:spcPts val="800"/>
+              </a:spcAft>
+            </a:pPr>
+            <a:r>
+              <a:rPr sz="1100" b="1" u="sng">
+                <a:solidFill>
+                  <a:srgbClr val="15803D"/>
+                </a:solidFill>
+                <a:latin typeface="Arial"/>
+              </a:rPr>
+              <a:t>• Artifact Exploration :
+</a:t>
+            </a:r>
+            <a:r>
+              <a:rPr sz="1050">
+                <a:solidFill>
+                  <a:srgbClr val="000000"/>
+                </a:solidFill>
+                <a:latin typeface="Arial"/>
+              </a:rPr>
+              <a:t>  Detailed digital exploration of cultural artifacts and their context.</a:t>
+            </a:r>
+          </a:p>
+          <a:p>
+            <a:pPr>
+              <a:spcAft>
+                <a:spcPts val="800"/>
+              </a:spcAft>
+            </a:pPr>
+            <a:r>
+              <a:rPr sz="1100" b="1" u="sng">
+                <a:solidFill>
+                  <a:srgbClr val="15803D"/>
+                </a:solidFill>
+                <a:latin typeface="Arial"/>
+              </a:rPr>
+              <a:t>• Responsible Heritage :
+</a:t>
+            </a:r>
+            <a:r>
+              <a:rPr sz="1050">
+                <a:solidFill>
+                  <a:srgbClr val="000000"/>
+                </a:solidFill>
+                <a:latin typeface="Arial"/>
+              </a:rPr>
+              <a:t>  Encourages informed and culturally responsible heritage discovery.</a:t>
+            </a:r>
+          </a:p>
+          <a:p>
+            <a:pPr>
+              <a:spcAft>
                 <a:spcPts val="400"/>
               </a:spcAft>
-              <a:defRPr sz="1800" b="1">
+            </a:pPr>
+            <a:r>
+              <a:rPr sz="1100" b="1" u="sng">
+                <a:solidFill>
+                  <a:srgbClr val="15803D"/>
+                </a:solidFill>
+                <a:latin typeface="Arial"/>
+              </a:rPr>
+              <a:t>• Core Differentiator :
+</a:t>
+            </a:r>
+            <a:r>
+              <a:rPr sz="1000" b="1">
+                <a:solidFill>
+                  <a:srgbClr val="475569"/>
+                </a:solidFill>
+                <a:latin typeface="Arial"/>
+              </a:rPr>
+              <a:t>  MOST PLATFORMS: “What is this place?”
+</a:t>
+            </a:r>
+            <a:r>
+              <a:rPr sz="1050" b="1">
                 <a:solidFill>
                   <a:srgbClr val="0070C0"/>
                 </a:solidFill>
                 <a:latin typeface="Arial"/>
-              </a:defRPr>
-            </a:pPr>
-            <a:r>
-              <a:t>❖ Viability:</a:t>
-            </a:r>
-          </a:p>
-          <a:p>
-            <a:pPr>
-              <a:spcAft>
-                <a:spcPts val="200"/>
+              </a:rPr>
+              <a:t>  VIRASATX: “How does this place connect to history, people, traditions, artifacts and living culture?”</a:t>
+            </a:r>
+          </a:p>
+          <a:p>
+            <a:pPr>
+              <a:spcAft>
+                <a:spcPts val="400"/>
               </a:spcAft>
             </a:pPr>
             <a:r>
@@ -5417,327 +5451,17 @@
                 </a:solidFill>
                 <a:latin typeface="Arial"/>
               </a:rPr>
-              <a:t>1. Economic Viability:</a:t>
-            </a:r>
-          </a:p>
-          <a:p>
-            <a:pPr>
-              <a:spcAft>
-                <a:spcPts val="100"/>
-              </a:spcAft>
-            </a:pPr>
-            <a:r>
-              <a:rPr sz="1050" b="1">
-                <a:solidFill>
-                  <a:srgbClr val="000000"/>
-                </a:solidFill>
-                <a:latin typeface="Arial"/>
-              </a:rPr>
-              <a:t>1.Cost-Effective &amp; Efficient:</a:t>
-            </a:r>
-          </a:p>
-          <a:p>
-            <a:pPr>
-              <a:spcAft>
-                <a:spcPts val="100"/>
-              </a:spcAft>
-            </a:pPr>
-            <a:r>
-              <a:rPr sz="1000">
-                <a:solidFill>
-                  <a:srgbClr val="000000"/>
-                </a:solidFill>
-                <a:latin typeface="Arial"/>
-              </a:rPr>
-              <a:t>  • Saves paperwork, effort, duplication, and reduces fraud.</a:t>
-            </a:r>
-          </a:p>
-          <a:p>
-            <a:pPr>
-              <a:spcAft>
-                <a:spcPts val="100"/>
-              </a:spcAft>
-            </a:pPr>
-            <a:r>
-              <a:rPr sz="1000">
-                <a:solidFill>
-                  <a:srgbClr val="000000"/>
-                </a:solidFill>
-                <a:latin typeface="Arial"/>
-              </a:rPr>
-              <a:t>  • Cuts processing delays, expenses, and operational overhead.</a:t>
-            </a:r>
-          </a:p>
-          <a:p>
-            <a:pPr>
-              <a:spcAft>
-                <a:spcPts val="100"/>
-              </a:spcAft>
-            </a:pPr>
-            <a:r>
-              <a:rPr sz="1050" b="1">
-                <a:solidFill>
-                  <a:srgbClr val="000000"/>
-                </a:solidFill>
-                <a:latin typeface="Arial"/>
-              </a:rPr>
-              <a:t>2. Supported &amp; Scalable Technology:</a:t>
-            </a:r>
-          </a:p>
-          <a:p>
-            <a:pPr>
-              <a:spcAft>
-                <a:spcPts val="100"/>
-              </a:spcAft>
-            </a:pPr>
-            <a:r>
-              <a:rPr sz="1000">
-                <a:solidFill>
-                  <a:srgbClr val="000000"/>
-                </a:solidFill>
-                <a:latin typeface="Arial"/>
-              </a:rPr>
-              <a:t>  • Backed by government programs and tribal inclusion schemes.</a:t>
-            </a:r>
-          </a:p>
-          <a:p>
-            <a:pPr>
-              <a:spcAft>
-                <a:spcPts val="100"/>
-              </a:spcAft>
-            </a:pPr>
-            <a:r>
-              <a:rPr sz="1000">
-                <a:solidFill>
-                  <a:srgbClr val="000000"/>
-                </a:solidFill>
-                <a:latin typeface="Arial"/>
-              </a:rPr>
-              <a:t>  • Open-source tech ensures flexible, low-cost,future-ready deployment.</a:t>
-            </a:r>
-          </a:p>
-          <a:p>
-            <a:pPr>
-              <a:spcAft>
-                <a:spcPts val="200"/>
-              </a:spcAft>
-            </a:pPr>
-            <a:r>
-              <a:rPr sz="1100" b="1" u="sng">
-                <a:solidFill>
-                  <a:srgbClr val="15803D"/>
-                </a:solidFill>
-                <a:latin typeface="Arial"/>
-              </a:rPr>
-              <a:t>2. Social Viability:</a:t>
-            </a:r>
-          </a:p>
-          <a:p>
-            <a:pPr>
-              <a:spcAft>
-                <a:spcPts val="100"/>
-              </a:spcAft>
-            </a:pPr>
-            <a:r>
-              <a:rPr sz="1050" b="1">
-                <a:solidFill>
-                  <a:srgbClr val="000000"/>
-                </a:solidFill>
-                <a:latin typeface="Arial"/>
-              </a:rPr>
-              <a:t>1. Empowers Communities &amp; Improves Scheme Access:</a:t>
-            </a:r>
-          </a:p>
-          <a:p>
-            <a:pPr>
-              <a:spcAft>
-                <a:spcPts val="100"/>
-              </a:spcAft>
-            </a:pPr>
-            <a:r>
-              <a:rPr sz="1000">
-                <a:solidFill>
-                  <a:srgbClr val="000000"/>
-                </a:solidFill>
-                <a:latin typeface="Arial"/>
-              </a:rPr>
-              <a:t>  • Provides transparency, secure records, better documentation.</a:t>
-            </a:r>
-          </a:p>
-          <a:p>
-            <a:pPr>
-              <a:spcAft>
-                <a:spcPts val="100"/>
-              </a:spcAft>
-            </a:pPr>
-            <a:r>
-              <a:rPr sz="1000">
-                <a:solidFill>
-                  <a:srgbClr val="000000"/>
-                </a:solidFill>
-                <a:latin typeface="Arial"/>
-              </a:rPr>
-              <a:t>  • Directly benefits artisans &amp; custodians through scheme access.</a:t>
-            </a:r>
-          </a:p>
-          <a:p>
-            <a:pPr>
-              <a:spcAft>
-                <a:spcPts val="100"/>
-              </a:spcAft>
-            </a:pPr>
-            <a:r>
-              <a:rPr sz="1050" b="1">
-                <a:solidFill>
-                  <a:srgbClr val="000000"/>
-                </a:solidFill>
-                <a:latin typeface="Arial"/>
-              </a:rPr>
-              <a:t>2. Reduces Conflict &amp; Promotes Stronger Inclusion:</a:t>
-            </a:r>
-          </a:p>
-          <a:p>
-            <a:pPr>
-              <a:spcAft>
-                <a:spcPts val="100"/>
-              </a:spcAft>
-            </a:pPr>
-            <a:r>
-              <a:rPr sz="1000">
-                <a:solidFill>
-                  <a:srgbClr val="000000"/>
-                </a:solidFill>
-                <a:latin typeface="Arial"/>
-              </a:rPr>
-              <a:t>  • Verified records, alerts reduce frequent attribution disputes.</a:t>
-            </a:r>
-          </a:p>
-          <a:p>
-            <a:pPr>
-              <a:spcAft>
-                <a:spcPts val="100"/>
-              </a:spcAft>
-            </a:pPr>
-            <a:r>
-              <a:rPr sz="1000">
-                <a:solidFill>
-                  <a:srgbClr val="000000"/>
-                </a:solidFill>
-                <a:latin typeface="Arial"/>
-              </a:rPr>
-              <a:t>  • Mobile updates, two-way communication improve engagement.</a:t>
-            </a:r>
-          </a:p>
-          <a:p>
-            <a:pPr>
-              <a:spcAft>
-                <a:spcPts val="200"/>
-              </a:spcAft>
-            </a:pPr>
-            <a:r>
-              <a:rPr sz="1100" b="1" u="sng">
-                <a:solidFill>
-                  <a:srgbClr val="15803D"/>
-                </a:solidFill>
-                <a:latin typeface="Arial"/>
-              </a:rPr>
-              <a:t>3. Scalability:</a:t>
-            </a:r>
-          </a:p>
-          <a:p>
-            <a:pPr>
-              <a:spcAft>
-                <a:spcPts val="100"/>
-              </a:spcAft>
-            </a:pPr>
-            <a:r>
-              <a:rPr sz="1050" b="1">
-                <a:solidFill>
-                  <a:srgbClr val="000000"/>
-                </a:solidFill>
-                <a:latin typeface="Arial"/>
-              </a:rPr>
-              <a:t>1. Pan-India Expansion for Wider Community Benefits:</a:t>
-            </a:r>
-          </a:p>
-          <a:p>
-            <a:pPr>
-              <a:spcAft>
-                <a:spcPts val="100"/>
-              </a:spcAft>
-            </a:pPr>
-            <a:r>
-              <a:rPr sz="1000">
-                <a:solidFill>
-                  <a:srgbClr val="000000"/>
-                </a:solidFill>
-                <a:latin typeface="Arial"/>
-              </a:rPr>
-              <a:t>  • Pilot in districts, then scale across India.</a:t>
-            </a:r>
-          </a:p>
-          <a:p>
-            <a:pPr>
-              <a:spcAft>
-                <a:spcPts val="100"/>
-              </a:spcAft>
-            </a:pPr>
-            <a:r>
-              <a:rPr sz="1000">
-                <a:solidFill>
-                  <a:srgbClr val="000000"/>
-                </a:solidFill>
-                <a:latin typeface="Arial"/>
-              </a:rPr>
-              <a:t>  • Adjust platform easily for local data.</a:t>
-            </a:r>
-          </a:p>
-          <a:p>
-            <a:pPr>
-              <a:spcAft>
-                <a:spcPts val="100"/>
-              </a:spcAft>
-            </a:pPr>
-            <a:r>
-              <a:rPr sz="1050" b="1">
-                <a:solidFill>
-                  <a:srgbClr val="000000"/>
-                </a:solidFill>
-                <a:latin typeface="Arial"/>
-              </a:rPr>
-              <a:t>2. Cross-Sector Use of WebGIS + DSS:</a:t>
-            </a:r>
-          </a:p>
-          <a:p>
-            <a:pPr>
-              <a:spcAft>
-                <a:spcPts val="100"/>
-              </a:spcAft>
-            </a:pPr>
-            <a:r>
-              <a:rPr sz="1000">
-                <a:solidFill>
-                  <a:srgbClr val="000000"/>
-                </a:solidFill>
-                <a:latin typeface="Arial"/>
-              </a:rPr>
-              <a:t>  • Adaptable for agriculture, urban development needs.</a:t>
-            </a:r>
-          </a:p>
-          <a:p>
-            <a:pPr>
-              <a:spcAft>
-                <a:spcPts val="100"/>
-              </a:spcAft>
-            </a:pPr>
-            <a:r>
-              <a:rPr sz="1000">
-                <a:solidFill>
-                  <a:srgbClr val="000000"/>
-                </a:solidFill>
-                <a:latin typeface="Arial"/>
-              </a:rPr>
-              <a:t>  • Useful in disaster management and planning.</a:t>
+              <a:t>• Context-First Experience :
+</a:t>
+            </a:r>
+            <a:r>
+              <a:rPr sz="1050">
+                <a:solidFill>
+                  <a:srgbClr val="000000"/>
+                </a:solidFill>
+                <a:latin typeface="Arial"/>
+              </a:rPr>
+              <a:t>  “VirasatX connects the cultural context around heritage — not just the heritage object itself.”</a:t>
             </a:r>
           </a:p>
         </p:txBody>
@@ -5870,7 +5594,7 @@
           <a:lstStyle/>
           <a:p>
             <a:pPr algn="ctr">
-              <a:defRPr sz="2400" b="1">
+              <a:defRPr sz="2200" b="1">
                 <a:solidFill>
                   <a:srgbClr val="000000"/>
                 </a:solidFill>
@@ -5878,7 +5602,7 @@
               </a:defRPr>
             </a:pPr>
             <a:r>
-              <a:t>IMPACT AND BENEFITS</a:t>
+              <a:t>FEASIBILITY, IMPACT &amp; SCALABILITY</a:t>
             </a:r>
           </a:p>
         </p:txBody>
@@ -6014,7 +5738,7 @@
               <a:spcAft>
                 <a:spcPts val="400"/>
               </a:spcAft>
-              <a:defRPr sz="1800" b="1">
+              <a:defRPr sz="1700" b="1">
                 <a:solidFill>
                   <a:srgbClr val="0070C0"/>
                 </a:solidFill>
@@ -6022,7 +5746,7 @@
               </a:defRPr>
             </a:pPr>
             <a:r>
-              <a:t>❖ Benefits:</a:t>
+              <a:t>❖ Feasibility &amp; Impact:</a:t>
             </a:r>
           </a:p>
           <a:p>
@@ -6038,7 +5762,7 @@
                 </a:solidFill>
                 <a:latin typeface="Arial"/>
               </a:rPr>
-              <a:t>1.Social Benefits:</a:t>
+              <a:t>1. Technical Feasibility:</a:t>
             </a:r>
           </a:p>
           <a:p>
@@ -6048,13 +5772,13 @@
               </a:spcAft>
             </a:pPr>
             <a:r>
-              <a:rPr sz="1000">
-                <a:solidFill>
-                  <a:srgbClr val="000000"/>
-                </a:solidFill>
-                <a:latin typeface="Arial"/>
-              </a:rPr>
-              <a:t>  • Digital platform enables communities with cultural rights tracking.</a:t>
+              <a:rPr sz="950">
+                <a:solidFill>
+                  <a:srgbClr val="000000"/>
+                </a:solidFill>
+                <a:latin typeface="Arial"/>
+              </a:rPr>
+              <a:t>  • Modern React-based web architecture with Vite and Tailwind CSS.</a:t>
             </a:r>
           </a:p>
           <a:p>
@@ -6064,13 +5788,13 @@
               </a:spcAft>
             </a:pPr>
             <a:r>
-              <a:rPr sz="1000">
-                <a:solidFill>
-                  <a:srgbClr val="000000"/>
-                </a:solidFill>
-                <a:latin typeface="Arial"/>
-              </a:rPr>
-              <a:t>  • IVR helpline, e-learning ensure inclusive literacy access.</a:t>
+              <a:rPr sz="950">
+                <a:solidFill>
+                  <a:srgbClr val="000000"/>
+                </a:solidFill>
+                <a:latin typeface="Arial"/>
+              </a:rPr>
+              <a:t>  • Modular AI capabilities powered by Google Gemini.</a:t>
             </a:r>
           </a:p>
           <a:p>
@@ -6080,13 +5804,61 @@
               </a:spcAft>
             </a:pPr>
             <a:r>
-              <a:rPr sz="1000">
-                <a:solidFill>
-                  <a:srgbClr val="000000"/>
-                </a:solidFill>
-                <a:latin typeface="Arial"/>
-              </a:rPr>
-              <a:t>  • Transparent records, video testimonies reduce conflict, build trust.</a:t>
+              <a:rPr sz="950">
+                <a:solidFill>
+                  <a:srgbClr val="000000"/>
+                </a:solidFill>
+                <a:latin typeface="Arial"/>
+              </a:rPr>
+              <a:t>  • Supabase-backed authentication and structured data services.</a:t>
+            </a:r>
+          </a:p>
+          <a:p>
+            <a:pPr>
+              <a:spcAft>
+                <a:spcPts val="150"/>
+              </a:spcAft>
+            </a:pPr>
+            <a:r>
+              <a:rPr sz="950">
+                <a:solidFill>
+                  <a:srgbClr val="000000"/>
+                </a:solidFill>
+                <a:latin typeface="Arial"/>
+              </a:rPr>
+              <a:t>  • Interactive mapping, 3D exploration, and multimedia.</a:t>
+            </a:r>
+          </a:p>
+          <a:p>
+            <a:pPr>
+              <a:spcAft>
+                <a:spcPts val="150"/>
+              </a:spcAft>
+            </a:pPr>
+            <a:r>
+              <a:rPr sz="950">
+                <a:solidFill>
+                  <a:srgbClr val="000000"/>
+                </a:solidFill>
+                <a:latin typeface="Arial"/>
+              </a:rPr>
+              <a:t>  • Responsive web interface deployed globally via Vercel.</a:t>
+            </a:r>
+          </a:p>
+          <a:p>
+            <a:pPr>
+              <a:spcAft>
+                <a:spcPts val="150"/>
+              </a:spcAft>
+            </a:pPr>
+            <a:r>
+              <a:rPr sz="950">
+                <a:solidFill>
+                  <a:srgbClr val="000000"/>
+                </a:solidFill>
+                <a:latin typeface="Arial"/>
+              </a:rPr>
+              <a:t>  • Expandable content architecture supporting new heritage categories.</a:t>
             </a:r>
           </a:p>
           <a:p>
@@ -6102,7 +5874,7 @@
                 </a:solidFill>
                 <a:latin typeface="Arial"/>
               </a:rPr>
-              <a:t>2. Environmental Benefits:</a:t>
+              <a:t>2. Social &amp; Cultural Impact:</a:t>
             </a:r>
           </a:p>
           <a:p>
@@ -6112,13 +5884,22 @@
               </a:spcAft>
             </a:pPr>
             <a:r>
-              <a:rPr sz="1000">
-                <a:solidFill>
-                  <a:srgbClr val="000000"/>
-                </a:solidFill>
-                <a:latin typeface="Arial"/>
-              </a:rPr>
-              <a:t>  • Sustainable site usage by recognized communities &amp; travelers.</a:t>
+              <a:rPr sz="950" b="1">
+                <a:solidFill>
+                  <a:srgbClr val="000000"/>
+                </a:solidFill>
+                <a:latin typeface="Arial"/>
+              </a:rPr>
+              <a:t>  • Preservation &amp; Discovery: </a:t>
+            </a:r>
+            <a:r>
+              <a:rPr sz="950">
+                <a:solidFill>
+                  <a:srgbClr val="000000"/>
+                </a:solidFill>
+                <a:latin typeface="Arial"/>
+              </a:rPr>
+              <a:t>Makes cultural information more discoverable through a unified digital experience.</a:t>
             </a:r>
           </a:p>
           <a:p>
@@ -6128,13 +5909,22 @@
               </a:spcAft>
             </a:pPr>
             <a:r>
-              <a:rPr sz="1000">
-                <a:solidFill>
-                  <a:srgbClr val="000000"/>
-                </a:solidFill>
-                <a:latin typeface="Arial"/>
-              </a:rPr>
-              <a:t>  • Conservation through community stewardship.</a:t>
+              <a:rPr sz="950" b="1">
+                <a:solidFill>
+                  <a:srgbClr val="000000"/>
+                </a:solidFill>
+                <a:latin typeface="Arial"/>
+              </a:rPr>
+              <a:t>  • Education: </a:t>
+            </a:r>
+            <a:r>
+              <a:rPr sz="950">
+                <a:solidFill>
+                  <a:srgbClr val="000000"/>
+                </a:solidFill>
+                <a:latin typeface="Arial"/>
+              </a:rPr>
+              <a:t>Transforms heritage discovery into an interactive learning experience.</a:t>
             </a:r>
           </a:p>
           <a:p>
@@ -6144,29 +5934,22 @@
               </a:spcAft>
             </a:pPr>
             <a:r>
-              <a:rPr sz="1000">
-                <a:solidFill>
-                  <a:srgbClr val="000000"/>
-                </a:solidFill>
-                <a:latin typeface="Arial"/>
-              </a:rPr>
-              <a:t>  • GI Tagging preserves cultural heritage &amp; traditional products.</a:t>
-            </a:r>
-          </a:p>
-          <a:p>
-            <a:pPr>
-              <a:spcAft>
-                <a:spcPts val="200"/>
-              </a:spcAft>
-            </a:pPr>
-            <a:r>
-              <a:rPr sz="1100" b="1" u="sng">
-                <a:solidFill>
-                  <a:srgbClr val="15803D"/>
-                </a:solidFill>
-                <a:latin typeface="Arial"/>
-              </a:rPr>
-              <a:t>3. Economic Benefits:</a:t>
+              <a:rPr sz="950" b="1">
+                <a:solidFill>
+                  <a:srgbClr val="000000"/>
+                </a:solidFill>
+                <a:latin typeface="Arial"/>
+              </a:rPr>
+              <a:t>  • Community Visibility: </a:t>
+            </a:r>
+            <a:r>
+              <a:rPr sz="950">
+                <a:solidFill>
+                  <a:srgbClr val="000000"/>
+                </a:solidFill>
+                <a:latin typeface="Arial"/>
+              </a:rPr>
+              <a:t>Creates a digital pathway for discovering living traditions, crafts and artisan communities.</a:t>
             </a:r>
           </a:p>
           <a:p>
@@ -6176,13 +5959,22 @@
               </a:spcAft>
             </a:pPr>
             <a:r>
-              <a:rPr sz="1000">
-                <a:solidFill>
-                  <a:srgbClr val="000000"/>
-                </a:solidFill>
-                <a:latin typeface="Arial"/>
-              </a:rPr>
-              <a:t>  • Access to schemes (MGNREGA, PM-KISAN, DAGAJU, Jal Jeevan Mission)</a:t>
+              <a:rPr sz="950" b="1">
+                <a:solidFill>
+                  <a:srgbClr val="000000"/>
+                </a:solidFill>
+                <a:latin typeface="Arial"/>
+              </a:rPr>
+              <a:t>  • Accessibility: </a:t>
+            </a:r>
+            <a:r>
+              <a:rPr sz="950">
+                <a:solidFill>
+                  <a:srgbClr val="000000"/>
+                </a:solidFill>
+                <a:latin typeface="Arial"/>
+              </a:rPr>
+              <a:t>Allows people to explore cultural knowledge beyond physical locations.</a:t>
             </a:r>
           </a:p>
           <a:p>
@@ -6192,157 +5984,22 @@
               </a:spcAft>
             </a:pPr>
             <a:r>
-              <a:rPr sz="1000">
-                <a:solidFill>
-                  <a:srgbClr val="000000"/>
-                </a:solidFill>
-                <a:latin typeface="Arial"/>
-              </a:rPr>
-              <a:t>  • GI Tagging boosts local products &amp; tribal livelihoods</a:t>
-            </a:r>
-          </a:p>
-          <a:p>
-            <a:pPr>
-              <a:spcAft>
-                <a:spcPts val="150"/>
-              </a:spcAft>
-            </a:pPr>
-            <a:r>
-              <a:rPr sz="1000">
-                <a:solidFill>
-                  <a:srgbClr val="000000"/>
-                </a:solidFill>
-                <a:latin typeface="Arial"/>
-              </a:rPr>
-              <a:t>  • Title insurance &amp; digital patta ensure secure land ownership → easier loans &amp; income stability</a:t>
-            </a:r>
-          </a:p>
-          <a:p>
-            <a:pPr>
-              <a:spcAft>
-                <a:spcPts val="200"/>
-              </a:spcAft>
-            </a:pPr>
-            <a:r>
-              <a:rPr sz="1100" b="1" u="sng">
-                <a:solidFill>
-                  <a:srgbClr val="15803D"/>
-                </a:solidFill>
-                <a:latin typeface="Arial"/>
-              </a:rPr>
-              <a:t>4. Governance Benefits:</a:t>
-            </a:r>
-          </a:p>
-          <a:p>
-            <a:pPr>
-              <a:spcAft>
-                <a:spcPts val="150"/>
-              </a:spcAft>
-            </a:pPr>
-            <a:r>
-              <a:rPr sz="1000">
-                <a:solidFill>
-                  <a:srgbClr val="000000"/>
-                </a:solidFill>
-                <a:latin typeface="Arial"/>
-              </a:rPr>
-              <a:t>  • Audit trails ensure accountability, prevent misuse.</a:t>
-            </a:r>
-          </a:p>
-          <a:p>
-            <a:pPr>
-              <a:spcAft>
-                <a:spcPts val="150"/>
-              </a:spcAft>
-            </a:pPr>
-            <a:r>
-              <a:rPr sz="1000">
-                <a:solidFill>
-                  <a:srgbClr val="000000"/>
-                </a:solidFill>
-                <a:latin typeface="Arial"/>
-              </a:rPr>
-              <a:t>  • Whistleblowing portal boosts transparency, fights corruption.</a:t>
-            </a:r>
-          </a:p>
-          <a:p>
-            <a:pPr>
-              <a:spcAft>
-                <a:spcPts val="150"/>
-              </a:spcAft>
-            </a:pPr>
-            <a:r>
-              <a:rPr sz="1000">
-                <a:solidFill>
-                  <a:srgbClr val="000000"/>
-                </a:solidFill>
-                <a:latin typeface="Arial"/>
-              </a:rPr>
-              <a:t>  • Cross-validation stops duplication and fraudulent claims.</a:t>
-            </a:r>
-          </a:p>
-          <a:p>
-            <a:pPr>
-              <a:spcAft>
-                <a:spcPts val="200"/>
-              </a:spcAft>
-            </a:pPr>
-            <a:r>
-              <a:rPr sz="1100" b="1" u="sng">
-                <a:solidFill>
-                  <a:srgbClr val="15803D"/>
-                </a:solidFill>
-                <a:latin typeface="Arial"/>
-              </a:rPr>
-              <a:t>5.Legal &amp; Security Benefits:</a:t>
-            </a:r>
-          </a:p>
-          <a:p>
-            <a:pPr>
-              <a:spcAft>
-                <a:spcPts val="150"/>
-              </a:spcAft>
-            </a:pPr>
-            <a:r>
-              <a:rPr sz="1000">
-                <a:solidFill>
-                  <a:srgbClr val="000000"/>
-                </a:solidFill>
-                <a:latin typeface="Arial"/>
-              </a:rPr>
-              <a:t>  • E-Signature &amp; Digital Patta provide legally valid ownership records.</a:t>
-            </a:r>
-          </a:p>
-          <a:p>
-            <a:pPr>
-              <a:spcAft>
-                <a:spcPts val="150"/>
-              </a:spcAft>
-            </a:pPr>
-            <a:r>
-              <a:rPr sz="1000">
-                <a:solidFill>
-                  <a:srgbClr val="000000"/>
-                </a:solidFill>
-                <a:latin typeface="Arial"/>
-              </a:rPr>
-              <a:t>  • Protection against land encroachment (Illegal Practice Alert).</a:t>
-            </a:r>
-          </a:p>
-          <a:p>
-            <a:pPr>
-              <a:spcAft>
-                <a:spcPts val="150"/>
-              </a:spcAft>
-            </a:pPr>
-            <a:r>
-              <a:rPr sz="1000">
-                <a:solidFill>
-                  <a:srgbClr val="000000"/>
-                </a:solidFill>
-                <a:latin typeface="Arial"/>
-              </a:rPr>
-              <a:t>  • Digital witness/testimony ensures fair dispute settlement.</a:t>
+              <a:rPr sz="950" b="1">
+                <a:solidFill>
+                  <a:srgbClr val="000000"/>
+                </a:solidFill>
+                <a:latin typeface="Arial"/>
+              </a:rPr>
+              <a:t>  • Responsible Discovery: </a:t>
+            </a:r>
+            <a:r>
+              <a:rPr sz="950">
+                <a:solidFill>
+                  <a:srgbClr val="000000"/>
+                </a:solidFill>
+                <a:latin typeface="Arial"/>
+              </a:rPr>
+              <a:t>Encourages understanding cultural context before visiting or interacting with heritage.</a:t>
             </a:r>
           </a:p>
         </p:txBody>
@@ -6418,7 +6075,7 @@
               <a:spcAft>
                 <a:spcPts val="400"/>
               </a:spcAft>
-              <a:defRPr sz="1800" b="1">
+              <a:defRPr sz="1700" b="1">
                 <a:solidFill>
                   <a:srgbClr val="0070C0"/>
                 </a:solidFill>
@@ -6426,7 +6083,7 @@
               </a:defRPr>
             </a:pPr>
             <a:r>
-              <a:t>❖ Impacts:</a:t>
+              <a:t>❖ Scalability &amp; Future Scope:</a:t>
             </a:r>
           </a:p>
           <a:p>
@@ -6442,7 +6099,7 @@
                 </a:solidFill>
                 <a:latin typeface="Arial"/>
               </a:rPr>
-              <a:t>1.Secure Cultural Rights &amp; Transparency:</a:t>
+              <a:t>1. Scalability Architecture:</a:t>
             </a:r>
           </a:p>
           <a:p>
@@ -6452,13 +6109,22 @@
               </a:spcAft>
             </a:pPr>
             <a:r>
-              <a:rPr sz="1000">
-                <a:solidFill>
-                  <a:srgbClr val="000000"/>
-                </a:solidFill>
-                <a:latin typeface="Arial"/>
-              </a:rPr>
-              <a:t>  • Communities track claims, reducing corruption and fraud.</a:t>
+              <a:rPr sz="950" b="1">
+                <a:solidFill>
+                  <a:srgbClr val="000000"/>
+                </a:solidFill>
+                <a:latin typeface="Arial"/>
+              </a:rPr>
+              <a:t>  • Scalability Progression: </a:t>
+            </a:r>
+            <a:r>
+              <a:rPr sz="950">
+                <a:solidFill>
+                  <a:srgbClr val="000000"/>
+                </a:solidFill>
+                <a:latin typeface="Arial"/>
+              </a:rPr>
+              <a:t>VirasatX MVP → Expanded Heritage Records → More Regions &amp; Languages → Institutional / Archive Integrations → Community Contribution → National-Scale Heritage Knowledge Platform.</a:t>
             </a:r>
           </a:p>
           <a:p>
@@ -6468,13 +6134,22 @@
               </a:spcAft>
             </a:pPr>
             <a:r>
-              <a:rPr sz="1000">
-                <a:solidFill>
-                  <a:srgbClr val="000000"/>
-                </a:solidFill>
-                <a:latin typeface="Arial"/>
-              </a:rPr>
-              <a:t>  • Digital patta ensures authenticity in land ownership records.</a:t>
+              <a:rPr sz="950" b="1">
+                <a:solidFill>
+                  <a:srgbClr val="000000"/>
+                </a:solidFill>
+                <a:latin typeface="Arial"/>
+              </a:rPr>
+              <a:t>  • Modular Expansion: </a:t>
+            </a:r>
+            <a:r>
+              <a:rPr sz="950">
+                <a:solidFill>
+                  <a:srgbClr val="000000"/>
+                </a:solidFill>
+                <a:latin typeface="Arial"/>
+              </a:rPr>
+              <a:t>Modular architecture allows adding regions and categories without system redesign.</a:t>
             </a:r>
           </a:p>
           <a:p>
@@ -6484,13 +6159,22 @@
               </a:spcAft>
             </a:pPr>
             <a:r>
-              <a:rPr sz="1000">
-                <a:solidFill>
-                  <a:srgbClr val="000000"/>
-                </a:solidFill>
-                <a:latin typeface="Arial"/>
-              </a:rPr>
-              <a:t>  • Builds trust between citizens and government authorities.</a:t>
+              <a:rPr sz="950" b="1">
+                <a:solidFill>
+                  <a:srgbClr val="000000"/>
+                </a:solidFill>
+                <a:latin typeface="Arial"/>
+              </a:rPr>
+              <a:t>  • Elastic Cloud Services: </a:t>
+            </a:r>
+            <a:r>
+              <a:rPr sz="950">
+                <a:solidFill>
+                  <a:srgbClr val="000000"/>
+                </a:solidFill>
+                <a:latin typeface="Arial"/>
+              </a:rPr>
+              <a:t>Serverless edge hosting through Vercel and Supabase scales on demand.</a:t>
             </a:r>
           </a:p>
           <a:p>
@@ -6506,7 +6190,7 @@
                 </a:solidFill>
                 <a:latin typeface="Arial"/>
               </a:rPr>
-              <a:t>2. Heritage Protection &amp; Conservation with AI:</a:t>
+              <a:t>2. Future Scope (Planned Enhancements):</a:t>
             </a:r>
           </a:p>
           <a:p>
@@ -6516,13 +6200,13 @@
               </a:spcAft>
             </a:pPr>
             <a:r>
-              <a:rPr sz="1000">
-                <a:solidFill>
-                  <a:srgbClr val="000000"/>
-                </a:solidFill>
-                <a:latin typeface="Arial"/>
-              </a:rPr>
-              <a:t>  • AI monitors land to prevent illegal encroachment.</a:t>
+              <a:rPr sz="950">
+                <a:solidFill>
+                  <a:srgbClr val="000000"/>
+                </a:solidFill>
+                <a:latin typeface="Arial"/>
+              </a:rPr>
+              <a:t>  • Indian-language expansion across additional regional languages.</a:t>
             </a:r>
           </a:p>
           <a:p>
@@ -6532,13 +6216,13 @@
               </a:spcAft>
             </a:pPr>
             <a:r>
-              <a:rPr sz="1000">
-                <a:solidFill>
-                  <a:srgbClr val="000000"/>
-                </a:solidFill>
-                <a:latin typeface="Arial"/>
-              </a:rPr>
-              <a:t>  • Conserves biodiversity and safeguards natural resources.</a:t>
+              <a:rPr sz="950">
+                <a:solidFill>
+                  <a:srgbClr val="000000"/>
+                </a:solidFill>
+                <a:latin typeface="Arial"/>
+              </a:rPr>
+              <a:t>  • Larger institutional datasets from archives and museum records.</a:t>
             </a:r>
           </a:p>
           <a:p>
@@ -6548,13 +6232,77 @@
               </a:spcAft>
             </a:pPr>
             <a:r>
-              <a:rPr sz="1000">
-                <a:solidFill>
-                  <a:srgbClr val="000000"/>
-                </a:solidFill>
-                <a:latin typeface="Arial"/>
-              </a:rPr>
-              <a:t>  • Promotes sustainable, community-driven cultural preservation.</a:t>
+              <a:rPr sz="950">
+                <a:solidFill>
+                  <a:srgbClr val="000000"/>
+                </a:solidFill>
+                <a:latin typeface="Arial"/>
+              </a:rPr>
+              <a:t>  • Community contribution workflows for grassroots cultural discovery.</a:t>
+            </a:r>
+          </a:p>
+          <a:p>
+            <a:pPr>
+              <a:spcAft>
+                <a:spcPts val="150"/>
+              </a:spcAft>
+            </a:pPr>
+            <a:r>
+              <a:rPr sz="950">
+                <a:solidFill>
+                  <a:srgbClr val="000000"/>
+                </a:solidFill>
+                <a:latin typeface="Arial"/>
+              </a:rPr>
+              <a:t>  • Advanced visual recognition for iconography.</a:t>
+            </a:r>
+          </a:p>
+          <a:p>
+            <a:pPr>
+              <a:spcAft>
+                <a:spcPts val="150"/>
+              </a:spcAft>
+            </a:pPr>
+            <a:r>
+              <a:rPr sz="950">
+                <a:solidFill>
+                  <a:srgbClr val="000000"/>
+                </a:solidFill>
+                <a:latin typeface="Arial"/>
+              </a:rPr>
+              <a:t>  • Richer 3D / immersive cultural experiences.</a:t>
+            </a:r>
+          </a:p>
+          <a:p>
+            <a:pPr>
+              <a:spcAft>
+                <a:spcPts val="150"/>
+              </a:spcAft>
+            </a:pPr>
+            <a:r>
+              <a:rPr sz="950">
+                <a:solidFill>
+                  <a:srgbClr val="000000"/>
+                </a:solidFill>
+                <a:latin typeface="Arial"/>
+              </a:rPr>
+              <a:t>  • Expanded educational modules and curricula integration.</a:t>
+            </a:r>
+          </a:p>
+          <a:p>
+            <a:pPr>
+              <a:spcAft>
+                <a:spcPts val="150"/>
+              </a:spcAft>
+            </a:pPr>
+            <a:r>
+              <a:rPr sz="950">
+                <a:solidFill>
+                  <a:srgbClr val="000000"/>
+                </a:solidFill>
+                <a:latin typeface="Arial"/>
+              </a:rPr>
+              <a:t>  • Museum and archive integrations.</a:t>
             </a:r>
           </a:p>
           <a:p>
@@ -6564,189 +6312,13 @@
               </a:spcAft>
             </a:pPr>
             <a:r>
-              <a:rPr sz="1100" b="1" u="sng">
-                <a:solidFill>
-                  <a:srgbClr val="15803D"/>
-                </a:solidFill>
-                <a:latin typeface="Arial"/>
-              </a:rPr>
-              <a:t>3. Boost Livelihoods &amp; Local Development:</a:t>
-            </a:r>
-          </a:p>
-          <a:p>
-            <a:pPr>
-              <a:spcAft>
-                <a:spcPts val="150"/>
-              </a:spcAft>
-            </a:pPr>
-            <a:r>
-              <a:rPr sz="1000">
-                <a:solidFill>
-                  <a:srgbClr val="000000"/>
-                </a:solidFill>
-                <a:latin typeface="Arial"/>
-              </a:rPr>
-              <a:t>  • Resource planning improves incomes and rural economy.</a:t>
-            </a:r>
-          </a:p>
-          <a:p>
-            <a:pPr>
-              <a:spcAft>
-                <a:spcPts val="150"/>
-              </a:spcAft>
-            </a:pPr>
-            <a:r>
-              <a:rPr sz="1000">
-                <a:solidFill>
-                  <a:srgbClr val="000000"/>
-                </a:solidFill>
-                <a:latin typeface="Arial"/>
-              </a:rPr>
-              <a:t>  • GI tagging protects heritage, boosts local products.</a:t>
-            </a:r>
-          </a:p>
-          <a:p>
-            <a:pPr>
-              <a:spcAft>
-                <a:spcPts val="150"/>
-              </a:spcAft>
-            </a:pPr>
-            <a:r>
-              <a:rPr sz="1000">
-                <a:solidFill>
-                  <a:srgbClr val="000000"/>
-                </a:solidFill>
-                <a:latin typeface="Arial"/>
-              </a:rPr>
-              <a:t>  • VirasatX enables fair access to welfare schemes.</a:t>
-            </a:r>
-          </a:p>
-          <a:p>
-            <a:pPr>
-              <a:spcAft>
-                <a:spcPts val="200"/>
-              </a:spcAft>
-            </a:pPr>
-            <a:r>
-              <a:rPr sz="1100" b="1" u="sng">
-                <a:solidFill>
-                  <a:srgbClr val="15803D"/>
-                </a:solidFill>
-                <a:latin typeface="Arial"/>
-              </a:rPr>
-              <a:t>4. Digital, Eco-Friendly &amp; Cost Effective:</a:t>
-            </a:r>
-          </a:p>
-          <a:p>
-            <a:pPr>
-              <a:spcAft>
-                <a:spcPts val="150"/>
-              </a:spcAft>
-            </a:pPr>
-            <a:r>
-              <a:rPr sz="1000">
-                <a:solidFill>
-                  <a:srgbClr val="000000"/>
-                </a:solidFill>
-                <a:latin typeface="Arial"/>
-              </a:rPr>
-              <a:t>  • Reduces paperwork,ensuring greener, eco-friendly governance.</a:t>
-            </a:r>
-          </a:p>
-          <a:p>
-            <a:pPr>
-              <a:spcAft>
-                <a:spcPts val="150"/>
-              </a:spcAft>
-            </a:pPr>
-            <a:r>
-              <a:rPr sz="1000">
-                <a:solidFill>
-                  <a:srgbClr val="000000"/>
-                </a:solidFill>
-                <a:latin typeface="Arial"/>
-              </a:rPr>
-              <a:t>  • Preserves tribal knowledge through digital archiving tools.</a:t>
-            </a:r>
-          </a:p>
-          <a:p>
-            <a:pPr>
-              <a:spcAft>
-                <a:spcPts val="150"/>
-              </a:spcAft>
-            </a:pPr>
-            <a:r>
-              <a:rPr sz="1000">
-                <a:solidFill>
-                  <a:srgbClr val="000000"/>
-                </a:solidFill>
-                <a:latin typeface="Arial"/>
-              </a:rPr>
-              <a:t>  • Lowers administrative costs and increases efficiency.</a:t>
-            </a:r>
-          </a:p>
-          <a:p>
-            <a:pPr>
-              <a:spcAft>
-                <a:spcPts val="200"/>
-              </a:spcAft>
-            </a:pPr>
-            <a:r>
-              <a:rPr sz="1100" b="1" u="sng">
-                <a:solidFill>
-                  <a:srgbClr val="15803D"/>
-                </a:solidFill>
-                <a:latin typeface="Arial"/>
-              </a:rPr>
-              <a:t>5. Smart, Transparent &amp; Scalable Governance:</a:t>
-            </a:r>
-          </a:p>
-          <a:p>
-            <a:pPr>
-              <a:spcAft>
-                <a:spcPts val="150"/>
-              </a:spcAft>
-            </a:pPr>
-            <a:r>
-              <a:rPr sz="1000">
-                <a:solidFill>
-                  <a:srgbClr val="000000"/>
-                </a:solidFill>
-                <a:latin typeface="Arial"/>
-              </a:rPr>
-              <a:t>  • Transparent dashboards track officer performance and claims.</a:t>
-            </a:r>
-          </a:p>
-          <a:p>
-            <a:pPr>
-              <a:spcAft>
-                <a:spcPts val="150"/>
-              </a:spcAft>
-            </a:pPr>
-            <a:r>
-              <a:rPr sz="1000">
-                <a:solidFill>
-                  <a:srgbClr val="000000"/>
-                </a:solidFill>
-                <a:latin typeface="Arial"/>
-              </a:rPr>
-              <a:t>  • AI dispute mediation ensures fairness, reduces human bias.</a:t>
-            </a:r>
-          </a:p>
-          <a:p>
-            <a:pPr>
-              <a:spcAft>
-                <a:spcPts val="150"/>
-              </a:spcAft>
-            </a:pPr>
-            <a:r>
-              <a:rPr sz="1000">
-                <a:solidFill>
-                  <a:srgbClr val="000000"/>
-                </a:solidFill>
-                <a:latin typeface="Arial"/>
-              </a:rPr>
-              <a:t>  • Unified digital platform enables future-ready expansion.</a:t>
+              <a:rPr sz="900" i="1">
+                <a:solidFill>
+                  <a:srgbClr val="475569"/>
+                </a:solidFill>
+                <a:latin typeface="Arial"/>
+              </a:rPr>
+              <a:t>  Note: The above items represent future scope and are not claimed as currently implemented.</a:t>
             </a:r>
           </a:p>
         </p:txBody>
@@ -6879,7 +6451,7 @@
           <a:lstStyle/>
           <a:p>
             <a:pPr algn="ctr">
-              <a:defRPr sz="2400" b="1">
+              <a:defRPr sz="2200" b="1">
                 <a:solidFill>
                   <a:srgbClr val="000000"/>
                 </a:solidFill>
@@ -7021,196 +6593,322 @@
           <a:p>
             <a:pPr>
               <a:spcAft>
-                <a:spcPts val="1000"/>
-              </a:spcAft>
-            </a:pPr>
-            <a:r>
-              <a:rPr sz="1150" b="1" u="sng">
+                <a:spcPts val="400"/>
+              </a:spcAft>
+            </a:pPr>
+            <a:r>
+              <a:rPr sz="1200" b="1" u="sng">
                 <a:solidFill>
                   <a:srgbClr val="15803D"/>
                 </a:solidFill>
                 <a:latin typeface="Arial"/>
               </a:rPr>
-              <a:t>1. AMASR Act &amp; NMM: </a:t>
-            </a:r>
-            <a:r>
-              <a:rPr sz="1100">
-                <a:solidFill>
-                  <a:srgbClr val="000000"/>
-                </a:solidFill>
-                <a:latin typeface="Arial"/>
-              </a:rPr>
-              <a:t>The Ancient Monuments and Archaeological Sites and Remains Act, 1958 and National Mission on Manuscripts (NMM) provide statutory framework for heritage protection.
-https://asi.nic.in/
-https://www.namami.gov.in/</a:t>
-            </a:r>
-          </a:p>
-          <a:p>
-            <a:pPr>
-              <a:spcAft>
-                <a:spcPts val="1000"/>
-              </a:spcAft>
-            </a:pPr>
-            <a:r>
-              <a:rPr sz="1150" b="1" u="sng">
+              <a:t>1. Project &amp; Prototype:</a:t>
+            </a:r>
+          </a:p>
+          <a:p>
+            <a:pPr>
+              <a:spcAft>
+                <a:spcPts val="200"/>
+              </a:spcAft>
+            </a:pPr>
+            <a:r>
+              <a:rPr sz="1100" b="1">
+                <a:solidFill>
+                  <a:srgbClr val="000000"/>
+                </a:solidFill>
+                <a:latin typeface="Arial"/>
+              </a:rPr>
+              <a:t>  • VirasatX — India’s Heritage Repository</a:t>
+            </a:r>
+          </a:p>
+          <a:p>
+            <a:pPr>
+              <a:spcAft>
+                <a:spcPts val="200"/>
+              </a:spcAft>
+            </a:pPr>
+            <a:r>
+              <a:rPr sz="1100" b="1">
+                <a:solidFill>
+                  <a:srgbClr val="0070C0"/>
+                </a:solidFill>
+                <a:latin typeface="Arial"/>
+              </a:rPr>
+              <a:t>  • Live Prototype: https://virasatxai.vercel.app/</a:t>
+            </a:r>
+          </a:p>
+          <a:p>
+            <a:pPr>
+              <a:spcAft>
+                <a:spcPts val="200"/>
+              </a:spcAft>
+            </a:pPr>
+            <a:r>
+              <a:rPr sz="1100" b="1">
+                <a:solidFill>
+                  <a:srgbClr val="0070C0"/>
+                </a:solidFill>
+                <a:latin typeface="Arial"/>
+              </a:rPr>
+              <a:t>  • GitHub Repository: https://github.com/ShrilCarpenter/VirasatX</a:t>
+            </a:r>
+          </a:p>
+          <a:p>
+            <a:pPr>
+              <a:spcAft>
+                <a:spcPts val="400"/>
+              </a:spcAft>
+            </a:pPr>
+            <a:r>
+              <a:rPr sz="1200" b="1" u="sng">
                 <a:solidFill>
                   <a:srgbClr val="15803D"/>
                 </a:solidFill>
                 <a:latin typeface="Arial"/>
               </a:rPr>
-              <a:t>2. Best Practices for Web Security: </a:t>
-            </a:r>
-            <a:r>
-              <a:rPr sz="1100">
-                <a:solidFill>
-                  <a:srgbClr val="000000"/>
-                </a:solidFill>
-                <a:latin typeface="Arial"/>
-              </a:rPr>
-              <a:t>OWASP Top 10 API Security &amp; Blockchain Verification Standard for Immutable Provenance.
-https://owasp.org/www-project-blockchain-appsec-standard/</a:t>
-            </a:r>
-          </a:p>
-          <a:p>
-            <a:pPr>
-              <a:spcAft>
-                <a:spcPts val="1000"/>
-              </a:spcAft>
-            </a:pPr>
-            <a:r>
-              <a:rPr sz="1150" b="1" u="sng">
+              <a:t>2. Research &amp; Reference Sources:</a:t>
+            </a:r>
+          </a:p>
+          <a:p>
+            <a:pPr>
+              <a:spcAft>
+                <a:spcPts val="200"/>
+              </a:spcAft>
+            </a:pPr>
+            <a:r>
+              <a:rPr sz="1050">
+                <a:solidFill>
+                  <a:srgbClr val="000000"/>
+                </a:solidFill>
+                <a:latin typeface="Arial"/>
+              </a:rPr>
+              <a:t>  Institutional sources consulted for taxonomy, cataloging schemas, and heritage documentation:</a:t>
+            </a:r>
+          </a:p>
+          <a:p>
+            <a:pPr>
+              <a:spcAft>
+                <a:spcPts val="150"/>
+              </a:spcAft>
+            </a:pPr>
+            <a:r>
+              <a:rPr sz="1000">
+                <a:solidFill>
+                  <a:srgbClr val="000000"/>
+                </a:solidFill>
+                <a:latin typeface="Arial"/>
+              </a:rPr>
+              <a:t>    • Ministry of Culture</a:t>
+            </a:r>
+            <a:r>
+              <a:rPr sz="950">
+                <a:solidFill>
+                  <a:srgbClr val="0070C0"/>
+                </a:solidFill>
+                <a:latin typeface="Arial"/>
+              </a:rPr>
+              <a:t> (https://www.indiaculture.gov.in/)</a:t>
+            </a:r>
+          </a:p>
+          <a:p>
+            <a:pPr>
+              <a:spcAft>
+                <a:spcPts val="150"/>
+              </a:spcAft>
+            </a:pPr>
+            <a:r>
+              <a:rPr sz="1000">
+                <a:solidFill>
+                  <a:srgbClr val="000000"/>
+                </a:solidFill>
+                <a:latin typeface="Arial"/>
+              </a:rPr>
+              <a:t>    • Archaeological Survey of India (ASI)</a:t>
+            </a:r>
+            <a:r>
+              <a:rPr sz="950">
+                <a:solidFill>
+                  <a:srgbClr val="0070C0"/>
+                </a:solidFill>
+                <a:latin typeface="Arial"/>
+              </a:rPr>
+              <a:t> (https://asi.nic.in/)</a:t>
+            </a:r>
+          </a:p>
+          <a:p>
+            <a:pPr>
+              <a:spcAft>
+                <a:spcPts val="150"/>
+              </a:spcAft>
+            </a:pPr>
+            <a:r>
+              <a:rPr sz="1000">
+                <a:solidFill>
+                  <a:srgbClr val="000000"/>
+                </a:solidFill>
+                <a:latin typeface="Arial"/>
+              </a:rPr>
+              <a:t>    • National Archives of India</a:t>
+            </a:r>
+            <a:r>
+              <a:rPr sz="950">
+                <a:solidFill>
+                  <a:srgbClr val="0070C0"/>
+                </a:solidFill>
+                <a:latin typeface="Arial"/>
+              </a:rPr>
+              <a:t> (https://nationalarchives.nic.in/)</a:t>
+            </a:r>
+          </a:p>
+          <a:p>
+            <a:pPr>
+              <a:spcAft>
+                <a:spcPts val="150"/>
+              </a:spcAft>
+            </a:pPr>
+            <a:r>
+              <a:rPr sz="1000">
+                <a:solidFill>
+                  <a:srgbClr val="000000"/>
+                </a:solidFill>
+                <a:latin typeface="Arial"/>
+              </a:rPr>
+              <a:t>    • National Mission on Monuments and Antiquities</a:t>
+            </a:r>
+          </a:p>
+          <a:p>
+            <a:pPr>
+              <a:spcAft>
+                <a:spcPts val="150"/>
+              </a:spcAft>
+            </a:pPr>
+            <a:r>
+              <a:rPr sz="1000">
+                <a:solidFill>
+                  <a:srgbClr val="000000"/>
+                </a:solidFill>
+                <a:latin typeface="Arial"/>
+              </a:rPr>
+              <a:t>    • Museums of India</a:t>
+            </a:r>
+            <a:r>
+              <a:rPr sz="950">
+                <a:solidFill>
+                  <a:srgbClr val="0070C0"/>
+                </a:solidFill>
+                <a:latin typeface="Arial"/>
+              </a:rPr>
+              <a:t> (https://museumsofindia.gov.in/)</a:t>
+            </a:r>
+          </a:p>
+          <a:p>
+            <a:pPr>
+              <a:spcAft>
+                <a:spcPts val="150"/>
+              </a:spcAft>
+            </a:pPr>
+            <a:r>
+              <a:rPr sz="1000">
+                <a:solidFill>
+                  <a:srgbClr val="000000"/>
+                </a:solidFill>
+                <a:latin typeface="Arial"/>
+              </a:rPr>
+              <a:t>    • Indira Gandhi National Centre for the Arts (IGNCA)</a:t>
+            </a:r>
+            <a:r>
+              <a:rPr sz="950">
+                <a:solidFill>
+                  <a:srgbClr val="0070C0"/>
+                </a:solidFill>
+                <a:latin typeface="Arial"/>
+              </a:rPr>
+              <a:t> (https://ignca.gov.in/)</a:t>
+            </a:r>
+          </a:p>
+          <a:p>
+            <a:pPr>
+              <a:spcAft>
+                <a:spcPts val="150"/>
+              </a:spcAft>
+            </a:pPr>
+            <a:r>
+              <a:rPr sz="1000">
+                <a:solidFill>
+                  <a:srgbClr val="000000"/>
+                </a:solidFill>
+                <a:latin typeface="Arial"/>
+              </a:rPr>
+              <a:t>    • Vedic Heritage Portal</a:t>
+            </a:r>
+            <a:r>
+              <a:rPr sz="950">
+                <a:solidFill>
+                  <a:srgbClr val="0070C0"/>
+                </a:solidFill>
+                <a:latin typeface="Arial"/>
+              </a:rPr>
+              <a:t> (https://vedicheritage.gov.in/)</a:t>
+            </a:r>
+          </a:p>
+          <a:p>
+            <a:pPr>
+              <a:spcAft>
+                <a:spcPts val="150"/>
+              </a:spcAft>
+            </a:pPr>
+            <a:r>
+              <a:rPr sz="1000">
+                <a:solidFill>
+                  <a:srgbClr val="000000"/>
+                </a:solidFill>
+                <a:latin typeface="Arial"/>
+              </a:rPr>
+              <a:t>    • UNESCO / Relevant Institutional Heritage Resources</a:t>
+            </a:r>
+            <a:r>
+              <a:rPr sz="950">
+                <a:solidFill>
+                  <a:srgbClr val="0070C0"/>
+                </a:solidFill>
+                <a:latin typeface="Arial"/>
+              </a:rPr>
+              <a:t> (https://whc.unesco.org/)</a:t>
+            </a:r>
+          </a:p>
+          <a:p>
+            <a:pPr>
+              <a:spcAft>
+                <a:spcPts val="400"/>
+              </a:spcAft>
+            </a:pPr>
+            <a:r>
+              <a:rPr sz="1200" b="1" u="sng">
                 <a:solidFill>
                   <a:srgbClr val="15803D"/>
                 </a:solidFill>
                 <a:latin typeface="Arial"/>
               </a:rPr>
-              <a:t>3. The Antiquities and Art Treasures Act: </a:t>
-            </a:r>
-            <a:r>
-              <a:rPr sz="1100">
-                <a:solidFill>
-                  <a:srgbClr val="000000"/>
-                </a:solidFill>
-                <a:latin typeface="Arial"/>
-              </a:rPr>
-              <a:t>1972 aims to regulate export trade in antiquities and art treasures, preventing illicit smuggling and unauthorized sales.
-https://asi.nic.in/antiquities-art-treasures-act/</a:t>
-            </a:r>
-          </a:p>
-          <a:p>
-            <a:pPr>
-              <a:spcAft>
-                <a:spcPts val="800"/>
-              </a:spcAft>
-            </a:pPr>
-            <a:r>
-              <a:rPr sz="1100">
-                <a:solidFill>
-                  <a:srgbClr val="000000"/>
-                </a:solidFill>
-                <a:latin typeface="Arial"/>
-              </a:rPr>
-              <a:t>To enable smooth implementation and integration of the Virasat Atlas System, the following contacts serve as official state-level resources for communication, data coordination, and support:</a:t>
-            </a:r>
-          </a:p>
-          <a:p>
-            <a:pPr>
-              <a:spcAft>
-                <a:spcPts val="500"/>
-              </a:spcAft>
-            </a:pPr>
-            <a:r>
-              <a:rPr sz="1100" b="1" u="sng">
-                <a:solidFill>
-                  <a:srgbClr val="15803D"/>
-                </a:solidFill>
-                <a:latin typeface="Arial"/>
-              </a:rPr>
-              <a:t>4. Archaeological Survey of India (ASI): </a:t>
-            </a:r>
-            <a:r>
-              <a:rPr sz="1100">
-                <a:solidFill>
-                  <a:srgbClr val="0070C0"/>
-                </a:solidFill>
-                <a:latin typeface="Arial"/>
-              </a:rPr>
-              <a:t>contact.asi@gov.in</a:t>
-            </a:r>
-          </a:p>
-          <a:p>
-            <a:pPr>
-              <a:spcAft>
-                <a:spcPts val="500"/>
-              </a:spcAft>
-            </a:pPr>
-            <a:r>
-              <a:rPr sz="1100" b="1" u="sng">
-                <a:solidFill>
-                  <a:srgbClr val="15803D"/>
-                </a:solidFill>
-                <a:latin typeface="Arial"/>
-              </a:rPr>
-              <a:t>5. National Mission on Manuscripts (IGNCA): </a:t>
-            </a:r>
-            <a:r>
-              <a:rPr sz="1100">
-                <a:solidFill>
-                  <a:srgbClr val="0070C0"/>
-                </a:solidFill>
-                <a:latin typeface="Arial"/>
-              </a:rPr>
-              <a:t>director.nmm@ignca.nic.in</a:t>
-            </a:r>
-          </a:p>
-          <a:p>
-            <a:pPr>
-              <a:spcAft>
-                <a:spcPts val="500"/>
-              </a:spcAft>
-            </a:pPr>
-            <a:r>
-              <a:rPr sz="1100" b="1" u="sng">
-                <a:solidFill>
-                  <a:srgbClr val="15803D"/>
-                </a:solidFill>
-                <a:latin typeface="Arial"/>
-              </a:rPr>
-              <a:t>6. Ministry of Culture, Govt. of India: </a:t>
-            </a:r>
-            <a:r>
-              <a:rPr sz="1100">
-                <a:solidFill>
-                  <a:srgbClr val="0070C0"/>
-                </a:solidFill>
-                <a:latin typeface="Arial"/>
-              </a:rPr>
-              <a:t>https://www.indiaculture.gov.in/</a:t>
-            </a:r>
-          </a:p>
-          <a:p>
-            <a:pPr>
-              <a:spcAft>
-                <a:spcPts val="500"/>
-              </a:spcAft>
-            </a:pPr>
-            <a:r>
-              <a:rPr sz="1100" b="1" u="sng">
-                <a:solidFill>
-                  <a:srgbClr val="15803D"/>
-                </a:solidFill>
-                <a:latin typeface="Arial"/>
-              </a:rPr>
-              <a:t>7. National Portal of India (Cultural Heritage): </a:t>
-            </a:r>
-            <a:r>
-              <a:rPr sz="1100">
-                <a:solidFill>
-                  <a:srgbClr val="0070C0"/>
-                </a:solidFill>
-                <a:latin typeface="Arial"/>
-              </a:rPr>
-              <a:t>https://www.india.gov.in/topics/art-culture</a:t>
+              <a:t>3. Closing Vision:</a:t>
+            </a:r>
+          </a:p>
+          <a:p>
+            <a:pPr>
+              <a:spcAft>
+                <a:spcPts val="200"/>
+              </a:spcAft>
+            </a:pPr>
+            <a:r>
+              <a:rPr sz="1050" b="1">
+                <a:solidFill>
+                  <a:srgbClr val="1B365D"/>
+                </a:solidFill>
+                <a:latin typeface="Arial"/>
+              </a:rPr>
+              <a:t>  VIRASATX — “From scattered heritage knowledge to one connected cultural experience.”
+  Explore. Understand. Preserve.
+  Smart India Hackathon 2026 — Problem Statement ID: SIH26197</a:t>
             </a:r>
           </a:p>
         </p:txBody>

</xml_diff>